<commit_message>
Remove the last two slides from the management presentation
</commit_message>
<xml_diff>
--- a/Presentacion_Gestion_Integral_2026.pptx
+++ b/Presentacion_Gestion_Integral_2026.pptx
@@ -15,8 +15,6 @@
     <p:sldId id="263" r:id="rId15"/>
     <p:sldId id="264" r:id="rId16"/>
     <p:sldId id="265" r:id="rId17"/>
-    <p:sldId id="266" r:id="rId18"/>
-    <p:sldId id="267" r:id="rId19"/>
   </p:sldIdLst>
   <p:sldSz cx="12191999" cy="6858000" type="screen4x3"/>
   <p:notesSz cx="6858000" cy="9144000"/>
@@ -584,146 +582,6 @@
           <a:p>
             <a:r>
               <a:t>Los informes originales de ProvinciaART informan82denuncias2025 y56en2026,16y25rechazos; gráficos norechazados66y31. Reducción denuncias31.7%, aumento rechazos56.25%, participación16/82=19.5% a25/56=44.6%. No se atribuye causalidad a gestión médica. Las frecuencias siniestral y judicial son12meses y no se usan como tasas9meses.</a:t>
-            </a:r>
-          </a:p>
-        </p:txBody>
-      </p:sp>
-      <p:sp>
-        <p:nvSpPr>
-          <p:cNvPr id="4" name="Slide Number Placeholder 3"/>
-          <p:cNvSpPr>
-            <a:spLocks noGrp="1"/>
-          </p:cNvSpPr>
-          <p:nvPr>
-            <p:ph type="sldNum" idx="5" sz="quarter"/>
-          </p:nvPr>
-        </p:nvSpPr>
-        <p:spPr/>
-      </p:sp>
-    </p:spTree>
-  </p:cSld>
-  <p:clrMapOvr>
-    <a:masterClrMapping/>
-  </p:clrMapOvr>
-</p:notes>
-</file>
-
-<file path=ppt/notesSlides/notesSlide11.xml><?xml version="1.0" encoding="utf-8"?>
-<p:notes xmlns:a="http://schemas.openxmlformats.org/drawingml/2006/main" xmlns:p="http://schemas.openxmlformats.org/presentationml/2006/main" xmlns:r="http://schemas.openxmlformats.org/officeDocument/2006/relationships">
-  <p:cSld>
-    <p:spTree>
-      <p:nvGrpSpPr>
-        <p:cNvPr id="1" name=""/>
-        <p:cNvGrpSpPr/>
-        <p:nvPr/>
-      </p:nvGrpSpPr>
-      <p:grpSpPr>
-        <a:xfrm>
-          <a:off x="0" y="0"/>
-          <a:ext cx="0" cy="0"/>
-          <a:chOff x="0" y="0"/>
-          <a:chExt cx="0" cy="0"/>
-        </a:xfrm>
-      </p:grpSpPr>
-      <p:sp>
-        <p:nvSpPr>
-          <p:cNvPr id="2" name="Slide Image Placeholder 1"/>
-          <p:cNvSpPr>
-            <a:spLocks noGrp="1"/>
-          </p:cNvSpPr>
-          <p:nvPr>
-            <p:ph type="sldImg" idx="2"/>
-          </p:nvPr>
-        </p:nvSpPr>
-        <p:spPr/>
-      </p:sp>
-      <p:sp>
-        <p:nvSpPr>
-          <p:cNvPr id="3" name="Notes Placeholder 2"/>
-          <p:cNvSpPr>
-            <a:spLocks noGrp="1"/>
-          </p:cNvSpPr>
-          <p:nvPr>
-            <p:ph type="body" idx="3" sz="quarter"/>
-          </p:nvPr>
-        </p:nvSpPr>
-        <p:spPr/>
-        <p:txBody>
-          <a:bodyPr/>
-          <a:lstStyle/>
-          <a:p>
-            <a:r>
-              <a:t>Planilla39inicios válidos (23AT12AI4EP),14menciones rechazo (9AT3AI2EP). Sin mención25 no aceptados confirmados. No existen fechas completas de resolución para todos. PDFART56denuncias25rechazos no muestra rechazos porcontingencia;16AT9AI6EP corresponde a norechazadosgráfico, nunca a rechazos. Diferencias56−39 y25−14 son agregadas, no casos faltantes identificados.</a:t>
-            </a:r>
-          </a:p>
-        </p:txBody>
-      </p:sp>
-      <p:sp>
-        <p:nvSpPr>
-          <p:cNvPr id="4" name="Slide Number Placeholder 3"/>
-          <p:cNvSpPr>
-            <a:spLocks noGrp="1"/>
-          </p:cNvSpPr>
-          <p:nvPr>
-            <p:ph type="sldNum" idx="5" sz="quarter"/>
-          </p:nvPr>
-        </p:nvSpPr>
-        <p:spPr/>
-      </p:sp>
-    </p:spTree>
-  </p:cSld>
-  <p:clrMapOvr>
-    <a:masterClrMapping/>
-  </p:clrMapOvr>
-</p:notes>
-</file>
-
-<file path=ppt/notesSlides/notesSlide12.xml><?xml version="1.0" encoding="utf-8"?>
-<p:notes xmlns:a="http://schemas.openxmlformats.org/drawingml/2006/main" xmlns:p="http://schemas.openxmlformats.org/presentationml/2006/main" xmlns:r="http://schemas.openxmlformats.org/officeDocument/2006/relationships">
-  <p:cSld>
-    <p:spTree>
-      <p:nvGrpSpPr>
-        <p:cNvPr id="1" name=""/>
-        <p:cNvGrpSpPr/>
-        <p:nvPr/>
-      </p:nvGrpSpPr>
-      <p:grpSpPr>
-        <a:xfrm>
-          <a:off x="0" y="0"/>
-          <a:ext cx="0" cy="0"/>
-          <a:chOff x="0" y="0"/>
-          <a:chExt cx="0" cy="0"/>
-        </a:xfrm>
-      </p:grpSpPr>
-      <p:sp>
-        <p:nvSpPr>
-          <p:cNvPr id="2" name="Slide Image Placeholder 1"/>
-          <p:cNvSpPr>
-            <a:spLocks noGrp="1"/>
-          </p:cNvSpPr>
-          <p:nvPr>
-            <p:ph type="sldImg" idx="2"/>
-          </p:nvPr>
-        </p:nvSpPr>
-        <p:spPr/>
-      </p:sp>
-      <p:sp>
-        <p:nvSpPr>
-          <p:cNvPr id="3" name="Notes Placeholder 2"/>
-          <p:cNvSpPr>
-            <a:spLocks noGrp="1"/>
-          </p:cNvSpPr>
-          <p:nvPr>
-            <p:ph type="body" idx="3" sz="quarter"/>
-          </p:nvPr>
-        </p:nvSpPr>
-        <p:spPr/>
-        <p:txBody>
-          <a:bodyPr/>
-          <a:lstStyle/>
-          <a:p>
-            <a:r>
-              <a:t>Planilla mide inicios por BAJA; portal denuncias segúncriterioART.39vs56y14vs25 son diferenciasagregadas, no17omisioneso11rechazosomitidos. Casosgraves2a4 yrecaídas3a8 enportal. Gráficosnorechazados66/31 frente tablasmensuales63/23. Deltas3/8 coincidenrecaídas3/8, hipótesis no explicitada porPDF. Frecuenciasportal12meses no comparables contasa9meses. No se publica informaciónnominal de rankingshistoricos.</a:t>
             </a:r>
           </a:p>
         </p:txBody>
@@ -6219,2828 +6077,6 @@
                 <a:latin typeface="DejaVu Sans"/>
               </a:rPr>
               <a:t>Menos denuncias y más rechazos: el comparativo no prueba la causa del cambio.</a:t>
-            </a:r>
-          </a:p>
-        </p:txBody>
-      </p:sp>
-    </p:spTree>
-  </p:cSld>
-  <p:clrMapOvr>
-    <a:masterClrMapping/>
-  </p:clrMapOvr>
-</p:sld>
-</file>
-
-<file path=ppt/slides/slide11.xml><?xml version="1.0" encoding="utf-8"?>
-<p:sld xmlns:a="http://schemas.openxmlformats.org/drawingml/2006/main" xmlns:p="http://schemas.openxmlformats.org/presentationml/2006/main" xmlns:r="http://schemas.openxmlformats.org/officeDocument/2006/relationships">
-  <p:cSld>
-    <p:bg>
-      <p:bgPr>
-        <a:solidFill>
-          <a:srgbClr val="FFFFFF"/>
-        </a:solidFill>
-        <a:effectLst/>
-      </p:bgPr>
-    </p:bg>
-    <p:spTree>
-      <p:nvGrpSpPr>
-        <p:cNvPr id="1" name=""/>
-        <p:cNvGrpSpPr/>
-        <p:nvPr/>
-      </p:nvGrpSpPr>
-      <p:grpSpPr/>
-      <p:sp>
-        <p:nvSpPr>
-          <p:cNvPr id="2" name="Rectangle 1"/>
-          <p:cNvSpPr/>
-          <p:nvPr/>
-        </p:nvSpPr>
-        <p:spPr>
-          <a:xfrm>
-            <a:off x="0" y="0"/>
-            <a:ext cx="12191999" cy="109728"/>
-          </a:xfrm>
-          <a:prstGeom prst="rect">
-            <a:avLst/>
-          </a:prstGeom>
-          <a:solidFill>
-            <a:srgbClr val="087F7A"/>
-          </a:solidFill>
-          <a:ln>
-            <a:noFill/>
-          </a:ln>
-        </p:spPr>
-        <p:style>
-          <a:lnRef idx="1">
-            <a:schemeClr val="accent1"/>
-          </a:lnRef>
-          <a:fillRef idx="3">
-            <a:schemeClr val="accent1"/>
-          </a:fillRef>
-          <a:effectRef idx="2">
-            <a:schemeClr val="accent1"/>
-          </a:effectRef>
-          <a:fontRef idx="minor">
-            <a:schemeClr val="lt1"/>
-          </a:fontRef>
-        </p:style>
-        <p:txBody>
-          <a:bodyPr rtlCol="0" anchor="ctr"/>
-          <a:lstStyle/>
-          <a:p>
-            <a:pPr algn="ctr"/>
-          </a:p>
-        </p:txBody>
-      </p:sp>
-      <p:sp>
-        <p:nvSpPr>
-          <p:cNvPr id="3" name="TextBox 2"/>
-          <p:cNvSpPr txBox="1"/>
-          <p:nvPr/>
-        </p:nvSpPr>
-        <p:spPr>
-          <a:xfrm>
-            <a:off x="566928" y="219456"/>
-            <a:ext cx="11064240" cy="292608"/>
-          </a:xfrm>
-          <a:prstGeom prst="rect">
-            <a:avLst/>
-          </a:prstGeom>
-          <a:noFill/>
-        </p:spPr>
-        <p:txBody>
-          <a:bodyPr wrap="square" lIns="22860" rIns="22860" tIns="22860" bIns="13716" anchor="t">
-            <a:spAutoFit/>
-          </a:bodyPr>
-          <a:lstStyle/>
-          <a:p>
-            <a:pPr algn="l">
-              <a:lnSpc>
-                <a:spcPct val="110000"/>
-              </a:lnSpc>
-              <a:spcAft>
-                <a:spcPts val="0"/>
-              </a:spcAft>
-            </a:pPr>
-            <a:r>
-              <a:rPr sz="1400" b="1">
-                <a:solidFill>
-                  <a:srgbClr val="087F7A"/>
-                </a:solidFill>
-                <a:latin typeface="DejaVu Sans"/>
-              </a:rPr>
-              <a:t>SERVICIO MÉDICO  /  TANDANOR</a:t>
-            </a:r>
-          </a:p>
-        </p:txBody>
-      </p:sp>
-      <p:sp>
-        <p:nvSpPr>
-          <p:cNvPr id="4" name="TextBox 3"/>
-          <p:cNvSpPr txBox="1"/>
-          <p:nvPr/>
-        </p:nvSpPr>
-        <p:spPr>
-          <a:xfrm>
-            <a:off x="566928" y="694944"/>
-            <a:ext cx="11064240" cy="502920"/>
-          </a:xfrm>
-          <a:prstGeom prst="rect">
-            <a:avLst/>
-          </a:prstGeom>
-          <a:noFill/>
-        </p:spPr>
-        <p:txBody>
-          <a:bodyPr wrap="square" lIns="22860" rIns="22860" tIns="22860" bIns="13716" anchor="t">
-            <a:spAutoFit/>
-          </a:bodyPr>
-          <a:lstStyle/>
-          <a:p>
-            <a:pPr algn="l">
-              <a:lnSpc>
-                <a:spcPct val="110000"/>
-              </a:lnSpc>
-              <a:spcAft>
-                <a:spcPts val="0"/>
-              </a:spcAft>
-            </a:pPr>
-            <a:r>
-              <a:rPr sz="2900" b="1">
-                <a:solidFill>
-                  <a:srgbClr val="17324D"/>
-                </a:solidFill>
-                <a:latin typeface="DejaVu Sans"/>
-              </a:rPr>
-              <a:t>Rechazos en la planilla: AT, AI y EP</a:t>
-            </a:r>
-          </a:p>
-        </p:txBody>
-      </p:sp>
-      <p:sp>
-        <p:nvSpPr>
-          <p:cNvPr id="5" name="TextBox 4"/>
-          <p:cNvSpPr txBox="1"/>
-          <p:nvPr/>
-        </p:nvSpPr>
-        <p:spPr>
-          <a:xfrm>
-            <a:off x="566928" y="1271016"/>
-            <a:ext cx="11064240" cy="384048"/>
-          </a:xfrm>
-          <a:prstGeom prst="rect">
-            <a:avLst/>
-          </a:prstGeom>
-          <a:noFill/>
-        </p:spPr>
-        <p:txBody>
-          <a:bodyPr wrap="square" lIns="22860" rIns="22860" tIns="22860" bIns="13716" anchor="t">
-            <a:spAutoFit/>
-          </a:bodyPr>
-          <a:lstStyle/>
-          <a:p>
-            <a:pPr algn="l">
-              <a:lnSpc>
-                <a:spcPct val="110000"/>
-              </a:lnSpc>
-              <a:spcAft>
-                <a:spcPts val="0"/>
-              </a:spcAft>
-            </a:pPr>
-            <a:r>
-              <a:rPr sz="1600" b="0">
-                <a:solidFill>
-                  <a:srgbClr val="586B7C"/>
-                </a:solidFill>
-                <a:latin typeface="DejaVu Sans"/>
-              </a:rPr>
-              <a:t>Casos con inicio entre enero y septiembre de 2026 · Estado consignado en la copia actual</a:t>
-            </a:r>
-          </a:p>
-        </p:txBody>
-      </p:sp>
-      <p:sp>
-        <p:nvSpPr>
-          <p:cNvPr id="6" name="Rectangle 5"/>
-          <p:cNvSpPr/>
-          <p:nvPr/>
-        </p:nvSpPr>
-        <p:spPr>
-          <a:xfrm>
-            <a:off x="566928" y="6364224"/>
-            <a:ext cx="11064240" cy="11887"/>
-          </a:xfrm>
-          <a:prstGeom prst="rect">
-            <a:avLst/>
-          </a:prstGeom>
-          <a:solidFill>
-            <a:srgbClr val="D6E2E8"/>
-          </a:solidFill>
-          <a:ln>
-            <a:noFill/>
-          </a:ln>
-        </p:spPr>
-        <p:style>
-          <a:lnRef idx="1">
-            <a:schemeClr val="accent1"/>
-          </a:lnRef>
-          <a:fillRef idx="3">
-            <a:schemeClr val="accent1"/>
-          </a:fillRef>
-          <a:effectRef idx="2">
-            <a:schemeClr val="accent1"/>
-          </a:effectRef>
-          <a:fontRef idx="minor">
-            <a:schemeClr val="lt1"/>
-          </a:fontRef>
-        </p:style>
-        <p:txBody>
-          <a:bodyPr rtlCol="0" anchor="ctr"/>
-          <a:lstStyle/>
-          <a:p>
-            <a:pPr algn="ctr"/>
-          </a:p>
-        </p:txBody>
-      </p:sp>
-      <p:sp>
-        <p:nvSpPr>
-          <p:cNvPr id="7" name="TextBox 6"/>
-          <p:cNvSpPr txBox="1"/>
-          <p:nvPr/>
-        </p:nvSpPr>
-        <p:spPr>
-          <a:xfrm>
-            <a:off x="566928" y="6473952"/>
-            <a:ext cx="9875520" cy="201168"/>
-          </a:xfrm>
-          <a:prstGeom prst="rect">
-            <a:avLst/>
-          </a:prstGeom>
-          <a:noFill/>
-        </p:spPr>
-        <p:txBody>
-          <a:bodyPr wrap="square" lIns="22860" rIns="22860" tIns="22860" bIns="13716" anchor="t">
-            <a:spAutoFit/>
-          </a:bodyPr>
-          <a:lstStyle/>
-          <a:p>
-            <a:pPr algn="l">
-              <a:lnSpc>
-                <a:spcPct val="110000"/>
-              </a:lnSpc>
-              <a:spcAft>
-                <a:spcPts val="0"/>
-              </a:spcAft>
-            </a:pPr>
-            <a:r>
-              <a:rPr sz="1150" b="0">
-                <a:solidFill>
-                  <a:srgbClr val="586B7C"/>
-                </a:solidFill>
-                <a:latin typeface="DejaVu Sans"/>
-              </a:rPr>
-              <a:t>Siniestralidad · Enero–septiembre  ·  8 de octubre de 2026  ·  Planilla Tandanor · ART / corte 30/09</a:t>
-            </a:r>
-          </a:p>
-        </p:txBody>
-      </p:sp>
-      <p:sp>
-        <p:nvSpPr>
-          <p:cNvPr id="8" name="TextBox 7"/>
-          <p:cNvSpPr txBox="1"/>
-          <p:nvPr/>
-        </p:nvSpPr>
-        <p:spPr>
-          <a:xfrm>
-            <a:off x="11045952" y="6455664"/>
-            <a:ext cx="530352" cy="228600"/>
-          </a:xfrm>
-          <a:prstGeom prst="rect">
-            <a:avLst/>
-          </a:prstGeom>
-          <a:noFill/>
-        </p:spPr>
-        <p:txBody>
-          <a:bodyPr wrap="square" lIns="22860" rIns="22860" tIns="22860" bIns="13716" anchor="t">
-            <a:spAutoFit/>
-          </a:bodyPr>
-          <a:lstStyle/>
-          <a:p>
-            <a:pPr algn="r">
-              <a:lnSpc>
-                <a:spcPct val="110000"/>
-              </a:lnSpc>
-              <a:spcAft>
-                <a:spcPts val="0"/>
-              </a:spcAft>
-            </a:pPr>
-            <a:r>
-              <a:rPr sz="1200" b="1">
-                <a:solidFill>
-                  <a:srgbClr val="087F7A"/>
-                </a:solidFill>
-                <a:latin typeface="DejaVu Sans"/>
-              </a:rPr>
-              <a:t>11</a:t>
-            </a:r>
-          </a:p>
-        </p:txBody>
-      </p:sp>
-      <p:sp>
-        <p:nvSpPr>
-          <p:cNvPr id="9" name="Rectangle 8"/>
-          <p:cNvSpPr/>
-          <p:nvPr/>
-        </p:nvSpPr>
-        <p:spPr>
-          <a:xfrm>
-            <a:off x="566928" y="1874519"/>
-            <a:ext cx="7488936" cy="667512"/>
-          </a:xfrm>
-          <a:prstGeom prst="rect">
-            <a:avLst/>
-          </a:prstGeom>
-          <a:solidFill>
-            <a:srgbClr val="17324D"/>
-          </a:solidFill>
-          <a:ln>
-            <a:noFill/>
-          </a:ln>
-        </p:spPr>
-        <p:style>
-          <a:lnRef idx="1">
-            <a:schemeClr val="accent1"/>
-          </a:lnRef>
-          <a:fillRef idx="3">
-            <a:schemeClr val="accent1"/>
-          </a:fillRef>
-          <a:effectRef idx="2">
-            <a:schemeClr val="accent1"/>
-          </a:effectRef>
-          <a:fontRef idx="minor">
-            <a:schemeClr val="lt1"/>
-          </a:fontRef>
-        </p:style>
-        <p:txBody>
-          <a:bodyPr rtlCol="0" anchor="ctr"/>
-          <a:lstStyle/>
-          <a:p>
-            <a:pPr algn="ctr"/>
-          </a:p>
-        </p:txBody>
-      </p:sp>
-      <p:sp>
-        <p:nvSpPr>
-          <p:cNvPr id="10" name="TextBox 9"/>
-          <p:cNvSpPr txBox="1"/>
-          <p:nvPr/>
-        </p:nvSpPr>
-        <p:spPr>
-          <a:xfrm>
-            <a:off x="658368" y="1956815"/>
-            <a:ext cx="3046506" cy="548640"/>
-          </a:xfrm>
-          <a:prstGeom prst="rect">
-            <a:avLst/>
-          </a:prstGeom>
-          <a:noFill/>
-        </p:spPr>
-        <p:txBody>
-          <a:bodyPr wrap="square" lIns="22860" rIns="22860" tIns="22860" bIns="13716" anchor="t">
-            <a:spAutoFit/>
-          </a:bodyPr>
-          <a:lstStyle/>
-          <a:p>
-            <a:pPr algn="l">
-              <a:lnSpc>
-                <a:spcPct val="110000"/>
-              </a:lnSpc>
-              <a:spcAft>
-                <a:spcPts val="0"/>
-              </a:spcAft>
-            </a:pPr>
-            <a:r>
-              <a:rPr sz="2400" b="1">
-                <a:solidFill>
-                  <a:srgbClr val="FFFFFF"/>
-                </a:solidFill>
-                <a:latin typeface="DejaVu Sans"/>
-              </a:rPr>
-              <a:t>Tipo</a:t>
-            </a:r>
-          </a:p>
-        </p:txBody>
-      </p:sp>
-      <p:sp>
-        <p:nvSpPr>
-          <p:cNvPr id="11" name="TextBox 10"/>
-          <p:cNvSpPr txBox="1"/>
-          <p:nvPr/>
-        </p:nvSpPr>
-        <p:spPr>
-          <a:xfrm>
-            <a:off x="3878610" y="1956815"/>
-            <a:ext cx="1324051" cy="548640"/>
-          </a:xfrm>
-          <a:prstGeom prst="rect">
-            <a:avLst/>
-          </a:prstGeom>
-          <a:noFill/>
-        </p:spPr>
-        <p:txBody>
-          <a:bodyPr wrap="square" lIns="22860" rIns="22860" tIns="22860" bIns="13716" anchor="t">
-            <a:spAutoFit/>
-          </a:bodyPr>
-          <a:lstStyle/>
-          <a:p>
-            <a:pPr algn="l">
-              <a:lnSpc>
-                <a:spcPct val="110000"/>
-              </a:lnSpc>
-              <a:spcAft>
-                <a:spcPts val="0"/>
-              </a:spcAft>
-            </a:pPr>
-            <a:r>
-              <a:rPr sz="2400" b="1">
-                <a:solidFill>
-                  <a:srgbClr val="FFFFFF"/>
-                </a:solidFill>
-                <a:latin typeface="DejaVu Sans"/>
-              </a:rPr>
-              <a:t>Inicios</a:t>
-            </a:r>
-          </a:p>
-        </p:txBody>
-      </p:sp>
-      <p:sp>
-        <p:nvSpPr>
-          <p:cNvPr id="12" name="TextBox 11"/>
-          <p:cNvSpPr txBox="1"/>
-          <p:nvPr/>
-        </p:nvSpPr>
-        <p:spPr>
-          <a:xfrm>
-            <a:off x="5376397" y="1956815"/>
-            <a:ext cx="2597170" cy="548640"/>
-          </a:xfrm>
-          <a:prstGeom prst="rect">
-            <a:avLst/>
-          </a:prstGeom>
-          <a:noFill/>
-        </p:spPr>
-        <p:txBody>
-          <a:bodyPr wrap="square" lIns="22860" rIns="22860" tIns="22860" bIns="13716" anchor="t">
-            <a:spAutoFit/>
-          </a:bodyPr>
-          <a:lstStyle/>
-          <a:p>
-            <a:pPr algn="l">
-              <a:lnSpc>
-                <a:spcPct val="110000"/>
-              </a:lnSpc>
-              <a:spcAft>
-                <a:spcPts val="0"/>
-              </a:spcAft>
-            </a:pPr>
-            <a:r>
-              <a:rPr sz="2400" b="1">
-                <a:solidFill>
-                  <a:srgbClr val="FFFFFF"/>
-                </a:solidFill>
-                <a:latin typeface="DejaVu Sans"/>
-              </a:rPr>
-              <a:t>Rechazos</a:t>
-            </a:r>
-          </a:p>
-        </p:txBody>
-      </p:sp>
-      <p:sp>
-        <p:nvSpPr>
-          <p:cNvPr id="13" name="Rectangle 12"/>
-          <p:cNvSpPr/>
-          <p:nvPr/>
-        </p:nvSpPr>
-        <p:spPr>
-          <a:xfrm>
-            <a:off x="566928" y="2542032"/>
-            <a:ext cx="7488936" cy="667512"/>
-          </a:xfrm>
-          <a:prstGeom prst="rect">
-            <a:avLst/>
-          </a:prstGeom>
-          <a:solidFill>
-            <a:srgbClr val="F3F6F8"/>
-          </a:solidFill>
-          <a:ln>
-            <a:noFill/>
-          </a:ln>
-        </p:spPr>
-        <p:style>
-          <a:lnRef idx="1">
-            <a:schemeClr val="accent1"/>
-          </a:lnRef>
-          <a:fillRef idx="3">
-            <a:schemeClr val="accent1"/>
-          </a:fillRef>
-          <a:effectRef idx="2">
-            <a:schemeClr val="accent1"/>
-          </a:effectRef>
-          <a:fontRef idx="minor">
-            <a:schemeClr val="lt1"/>
-          </a:fontRef>
-        </p:style>
-        <p:txBody>
-          <a:bodyPr rtlCol="0" anchor="ctr"/>
-          <a:lstStyle/>
-          <a:p>
-            <a:pPr algn="ctr"/>
-          </a:p>
-        </p:txBody>
-      </p:sp>
-      <p:sp>
-        <p:nvSpPr>
-          <p:cNvPr id="14" name="TextBox 13"/>
-          <p:cNvSpPr txBox="1"/>
-          <p:nvPr/>
-        </p:nvSpPr>
-        <p:spPr>
-          <a:xfrm>
-            <a:off x="658368" y="2624327"/>
-            <a:ext cx="3046506" cy="548640"/>
-          </a:xfrm>
-          <a:prstGeom prst="rect">
-            <a:avLst/>
-          </a:prstGeom>
-          <a:noFill/>
-        </p:spPr>
-        <p:txBody>
-          <a:bodyPr wrap="square" lIns="22860" rIns="22860" tIns="22860" bIns="13716" anchor="t">
-            <a:spAutoFit/>
-          </a:bodyPr>
-          <a:lstStyle/>
-          <a:p>
-            <a:pPr algn="l">
-              <a:lnSpc>
-                <a:spcPct val="110000"/>
-              </a:lnSpc>
-              <a:spcAft>
-                <a:spcPts val="0"/>
-              </a:spcAft>
-            </a:pPr>
-            <a:r>
-              <a:rPr sz="2400" b="1">
-                <a:solidFill>
-                  <a:srgbClr val="17324D"/>
-                </a:solidFill>
-                <a:latin typeface="DejaVu Sans"/>
-              </a:rPr>
-              <a:t>AT · Trabajo</a:t>
-            </a:r>
-          </a:p>
-        </p:txBody>
-      </p:sp>
-      <p:sp>
-        <p:nvSpPr>
-          <p:cNvPr id="15" name="TextBox 14"/>
-          <p:cNvSpPr txBox="1"/>
-          <p:nvPr/>
-        </p:nvSpPr>
-        <p:spPr>
-          <a:xfrm>
-            <a:off x="3878610" y="2624327"/>
-            <a:ext cx="1324051" cy="548640"/>
-          </a:xfrm>
-          <a:prstGeom prst="rect">
-            <a:avLst/>
-          </a:prstGeom>
-          <a:noFill/>
-        </p:spPr>
-        <p:txBody>
-          <a:bodyPr wrap="square" lIns="22860" rIns="22860" tIns="22860" bIns="13716" anchor="t">
-            <a:spAutoFit/>
-          </a:bodyPr>
-          <a:lstStyle/>
-          <a:p>
-            <a:pPr algn="l">
-              <a:lnSpc>
-                <a:spcPct val="110000"/>
-              </a:lnSpc>
-              <a:spcAft>
-                <a:spcPts val="0"/>
-              </a:spcAft>
-            </a:pPr>
-            <a:r>
-              <a:rPr sz="2400" b="0">
-                <a:solidFill>
-                  <a:srgbClr val="17324D"/>
-                </a:solidFill>
-                <a:latin typeface="DejaVu Sans"/>
-              </a:rPr>
-              <a:t>23</a:t>
-            </a:r>
-          </a:p>
-        </p:txBody>
-      </p:sp>
-      <p:sp>
-        <p:nvSpPr>
-          <p:cNvPr id="16" name="TextBox 15"/>
-          <p:cNvSpPr txBox="1"/>
-          <p:nvPr/>
-        </p:nvSpPr>
-        <p:spPr>
-          <a:xfrm>
-            <a:off x="5376397" y="2624327"/>
-            <a:ext cx="2597170" cy="548640"/>
-          </a:xfrm>
-          <a:prstGeom prst="rect">
-            <a:avLst/>
-          </a:prstGeom>
-          <a:noFill/>
-        </p:spPr>
-        <p:txBody>
-          <a:bodyPr wrap="square" lIns="22860" rIns="22860" tIns="22860" bIns="13716" anchor="t">
-            <a:spAutoFit/>
-          </a:bodyPr>
-          <a:lstStyle/>
-          <a:p>
-            <a:pPr algn="l">
-              <a:lnSpc>
-                <a:spcPct val="110000"/>
-              </a:lnSpc>
-              <a:spcAft>
-                <a:spcPts val="0"/>
-              </a:spcAft>
-            </a:pPr>
-            <a:r>
-              <a:rPr sz="2400" b="0">
-                <a:solidFill>
-                  <a:srgbClr val="17324D"/>
-                </a:solidFill>
-                <a:latin typeface="DejaVu Sans"/>
-              </a:rPr>
-              <a:t>9</a:t>
-            </a:r>
-          </a:p>
-        </p:txBody>
-      </p:sp>
-      <p:sp>
-        <p:nvSpPr>
-          <p:cNvPr id="17" name="Rectangle 16"/>
-          <p:cNvSpPr/>
-          <p:nvPr/>
-        </p:nvSpPr>
-        <p:spPr>
-          <a:xfrm>
-            <a:off x="566928" y="3209544"/>
-            <a:ext cx="7488936" cy="667512"/>
-          </a:xfrm>
-          <a:prstGeom prst="rect">
-            <a:avLst/>
-          </a:prstGeom>
-          <a:solidFill>
-            <a:srgbClr val="FFFFFF"/>
-          </a:solidFill>
-          <a:ln>
-            <a:noFill/>
-          </a:ln>
-        </p:spPr>
-        <p:style>
-          <a:lnRef idx="1">
-            <a:schemeClr val="accent1"/>
-          </a:lnRef>
-          <a:fillRef idx="3">
-            <a:schemeClr val="accent1"/>
-          </a:fillRef>
-          <a:effectRef idx="2">
-            <a:schemeClr val="accent1"/>
-          </a:effectRef>
-          <a:fontRef idx="minor">
-            <a:schemeClr val="lt1"/>
-          </a:fontRef>
-        </p:style>
-        <p:txBody>
-          <a:bodyPr rtlCol="0" anchor="ctr"/>
-          <a:lstStyle/>
-          <a:p>
-            <a:pPr algn="ctr"/>
-          </a:p>
-        </p:txBody>
-      </p:sp>
-      <p:sp>
-        <p:nvSpPr>
-          <p:cNvPr id="18" name="TextBox 17"/>
-          <p:cNvSpPr txBox="1"/>
-          <p:nvPr/>
-        </p:nvSpPr>
-        <p:spPr>
-          <a:xfrm>
-            <a:off x="658368" y="3291839"/>
-            <a:ext cx="3046506" cy="548640"/>
-          </a:xfrm>
-          <a:prstGeom prst="rect">
-            <a:avLst/>
-          </a:prstGeom>
-          <a:noFill/>
-        </p:spPr>
-        <p:txBody>
-          <a:bodyPr wrap="square" lIns="22860" rIns="22860" tIns="22860" bIns="13716" anchor="t">
-            <a:spAutoFit/>
-          </a:bodyPr>
-          <a:lstStyle/>
-          <a:p>
-            <a:pPr algn="l">
-              <a:lnSpc>
-                <a:spcPct val="110000"/>
-              </a:lnSpc>
-              <a:spcAft>
-                <a:spcPts val="0"/>
-              </a:spcAft>
-            </a:pPr>
-            <a:r>
-              <a:rPr sz="2400" b="1">
-                <a:solidFill>
-                  <a:srgbClr val="17324D"/>
-                </a:solidFill>
-                <a:latin typeface="DejaVu Sans"/>
-              </a:rPr>
-              <a:t>AI · In itinere</a:t>
-            </a:r>
-          </a:p>
-        </p:txBody>
-      </p:sp>
-      <p:sp>
-        <p:nvSpPr>
-          <p:cNvPr id="19" name="TextBox 18"/>
-          <p:cNvSpPr txBox="1"/>
-          <p:nvPr/>
-        </p:nvSpPr>
-        <p:spPr>
-          <a:xfrm>
-            <a:off x="3878610" y="3291839"/>
-            <a:ext cx="1324051" cy="548640"/>
-          </a:xfrm>
-          <a:prstGeom prst="rect">
-            <a:avLst/>
-          </a:prstGeom>
-          <a:noFill/>
-        </p:spPr>
-        <p:txBody>
-          <a:bodyPr wrap="square" lIns="22860" rIns="22860" tIns="22860" bIns="13716" anchor="t">
-            <a:spAutoFit/>
-          </a:bodyPr>
-          <a:lstStyle/>
-          <a:p>
-            <a:pPr algn="l">
-              <a:lnSpc>
-                <a:spcPct val="110000"/>
-              </a:lnSpc>
-              <a:spcAft>
-                <a:spcPts val="0"/>
-              </a:spcAft>
-            </a:pPr>
-            <a:r>
-              <a:rPr sz="2400" b="0">
-                <a:solidFill>
-                  <a:srgbClr val="17324D"/>
-                </a:solidFill>
-                <a:latin typeface="DejaVu Sans"/>
-              </a:rPr>
-              <a:t>12</a:t>
-            </a:r>
-          </a:p>
-        </p:txBody>
-      </p:sp>
-      <p:sp>
-        <p:nvSpPr>
-          <p:cNvPr id="20" name="TextBox 19"/>
-          <p:cNvSpPr txBox="1"/>
-          <p:nvPr/>
-        </p:nvSpPr>
-        <p:spPr>
-          <a:xfrm>
-            <a:off x="5376397" y="3291839"/>
-            <a:ext cx="2597170" cy="548640"/>
-          </a:xfrm>
-          <a:prstGeom prst="rect">
-            <a:avLst/>
-          </a:prstGeom>
-          <a:noFill/>
-        </p:spPr>
-        <p:txBody>
-          <a:bodyPr wrap="square" lIns="22860" rIns="22860" tIns="22860" bIns="13716" anchor="t">
-            <a:spAutoFit/>
-          </a:bodyPr>
-          <a:lstStyle/>
-          <a:p>
-            <a:pPr algn="l">
-              <a:lnSpc>
-                <a:spcPct val="110000"/>
-              </a:lnSpc>
-              <a:spcAft>
-                <a:spcPts val="0"/>
-              </a:spcAft>
-            </a:pPr>
-            <a:r>
-              <a:rPr sz="2400" b="0">
-                <a:solidFill>
-                  <a:srgbClr val="17324D"/>
-                </a:solidFill>
-                <a:latin typeface="DejaVu Sans"/>
-              </a:rPr>
-              <a:t>3</a:t>
-            </a:r>
-          </a:p>
-        </p:txBody>
-      </p:sp>
-      <p:sp>
-        <p:nvSpPr>
-          <p:cNvPr id="21" name="Rectangle 20"/>
-          <p:cNvSpPr/>
-          <p:nvPr/>
-        </p:nvSpPr>
-        <p:spPr>
-          <a:xfrm>
-            <a:off x="566928" y="3877056"/>
-            <a:ext cx="7488936" cy="667512"/>
-          </a:xfrm>
-          <a:prstGeom prst="rect">
-            <a:avLst/>
-          </a:prstGeom>
-          <a:solidFill>
-            <a:srgbClr val="F3F6F8"/>
-          </a:solidFill>
-          <a:ln>
-            <a:noFill/>
-          </a:ln>
-        </p:spPr>
-        <p:style>
-          <a:lnRef idx="1">
-            <a:schemeClr val="accent1"/>
-          </a:lnRef>
-          <a:fillRef idx="3">
-            <a:schemeClr val="accent1"/>
-          </a:fillRef>
-          <a:effectRef idx="2">
-            <a:schemeClr val="accent1"/>
-          </a:effectRef>
-          <a:fontRef idx="minor">
-            <a:schemeClr val="lt1"/>
-          </a:fontRef>
-        </p:style>
-        <p:txBody>
-          <a:bodyPr rtlCol="0" anchor="ctr"/>
-          <a:lstStyle/>
-          <a:p>
-            <a:pPr algn="ctr"/>
-          </a:p>
-        </p:txBody>
-      </p:sp>
-      <p:sp>
-        <p:nvSpPr>
-          <p:cNvPr id="22" name="TextBox 21"/>
-          <p:cNvSpPr txBox="1"/>
-          <p:nvPr/>
-        </p:nvSpPr>
-        <p:spPr>
-          <a:xfrm>
-            <a:off x="658368" y="3959352"/>
-            <a:ext cx="3046506" cy="548640"/>
-          </a:xfrm>
-          <a:prstGeom prst="rect">
-            <a:avLst/>
-          </a:prstGeom>
-          <a:noFill/>
-        </p:spPr>
-        <p:txBody>
-          <a:bodyPr wrap="square" lIns="22860" rIns="22860" tIns="22860" bIns="13716" anchor="t">
-            <a:spAutoFit/>
-          </a:bodyPr>
-          <a:lstStyle/>
-          <a:p>
-            <a:pPr algn="l">
-              <a:lnSpc>
-                <a:spcPct val="110000"/>
-              </a:lnSpc>
-              <a:spcAft>
-                <a:spcPts val="0"/>
-              </a:spcAft>
-            </a:pPr>
-            <a:r>
-              <a:rPr sz="2400" b="1">
-                <a:solidFill>
-                  <a:srgbClr val="17324D"/>
-                </a:solidFill>
-                <a:latin typeface="DejaVu Sans"/>
-              </a:rPr>
-              <a:t>EP · Profesional</a:t>
-            </a:r>
-          </a:p>
-        </p:txBody>
-      </p:sp>
-      <p:sp>
-        <p:nvSpPr>
-          <p:cNvPr id="23" name="TextBox 22"/>
-          <p:cNvSpPr txBox="1"/>
-          <p:nvPr/>
-        </p:nvSpPr>
-        <p:spPr>
-          <a:xfrm>
-            <a:off x="3878610" y="3959352"/>
-            <a:ext cx="1324051" cy="548640"/>
-          </a:xfrm>
-          <a:prstGeom prst="rect">
-            <a:avLst/>
-          </a:prstGeom>
-          <a:noFill/>
-        </p:spPr>
-        <p:txBody>
-          <a:bodyPr wrap="square" lIns="22860" rIns="22860" tIns="22860" bIns="13716" anchor="t">
-            <a:spAutoFit/>
-          </a:bodyPr>
-          <a:lstStyle/>
-          <a:p>
-            <a:pPr algn="l">
-              <a:lnSpc>
-                <a:spcPct val="110000"/>
-              </a:lnSpc>
-              <a:spcAft>
-                <a:spcPts val="0"/>
-              </a:spcAft>
-            </a:pPr>
-            <a:r>
-              <a:rPr sz="2400" b="0">
-                <a:solidFill>
-                  <a:srgbClr val="17324D"/>
-                </a:solidFill>
-                <a:latin typeface="DejaVu Sans"/>
-              </a:rPr>
-              <a:t>4</a:t>
-            </a:r>
-          </a:p>
-        </p:txBody>
-      </p:sp>
-      <p:sp>
-        <p:nvSpPr>
-          <p:cNvPr id="24" name="TextBox 23"/>
-          <p:cNvSpPr txBox="1"/>
-          <p:nvPr/>
-        </p:nvSpPr>
-        <p:spPr>
-          <a:xfrm>
-            <a:off x="5376397" y="3959352"/>
-            <a:ext cx="2597170" cy="548640"/>
-          </a:xfrm>
-          <a:prstGeom prst="rect">
-            <a:avLst/>
-          </a:prstGeom>
-          <a:noFill/>
-        </p:spPr>
-        <p:txBody>
-          <a:bodyPr wrap="square" lIns="22860" rIns="22860" tIns="22860" bIns="13716" anchor="t">
-            <a:spAutoFit/>
-          </a:bodyPr>
-          <a:lstStyle/>
-          <a:p>
-            <a:pPr algn="l">
-              <a:lnSpc>
-                <a:spcPct val="110000"/>
-              </a:lnSpc>
-              <a:spcAft>
-                <a:spcPts val="0"/>
-              </a:spcAft>
-            </a:pPr>
-            <a:r>
-              <a:rPr sz="2400" b="0">
-                <a:solidFill>
-                  <a:srgbClr val="17324D"/>
-                </a:solidFill>
-                <a:latin typeface="DejaVu Sans"/>
-              </a:rPr>
-              <a:t>2</a:t>
-            </a:r>
-          </a:p>
-        </p:txBody>
-      </p:sp>
-      <p:sp>
-        <p:nvSpPr>
-          <p:cNvPr id="25" name="Rectangle 24"/>
-          <p:cNvSpPr/>
-          <p:nvPr/>
-        </p:nvSpPr>
-        <p:spPr>
-          <a:xfrm>
-            <a:off x="566928" y="4544568"/>
-            <a:ext cx="7488936" cy="667512"/>
-          </a:xfrm>
-          <a:prstGeom prst="rect">
-            <a:avLst/>
-          </a:prstGeom>
-          <a:solidFill>
-            <a:srgbClr val="FFFFFF"/>
-          </a:solidFill>
-          <a:ln>
-            <a:noFill/>
-          </a:ln>
-        </p:spPr>
-        <p:style>
-          <a:lnRef idx="1">
-            <a:schemeClr val="accent1"/>
-          </a:lnRef>
-          <a:fillRef idx="3">
-            <a:schemeClr val="accent1"/>
-          </a:fillRef>
-          <a:effectRef idx="2">
-            <a:schemeClr val="accent1"/>
-          </a:effectRef>
-          <a:fontRef idx="minor">
-            <a:schemeClr val="lt1"/>
-          </a:fontRef>
-        </p:style>
-        <p:txBody>
-          <a:bodyPr rtlCol="0" anchor="ctr"/>
-          <a:lstStyle/>
-          <a:p>
-            <a:pPr algn="ctr"/>
-          </a:p>
-        </p:txBody>
-      </p:sp>
-      <p:sp>
-        <p:nvSpPr>
-          <p:cNvPr id="26" name="TextBox 25"/>
-          <p:cNvSpPr txBox="1"/>
-          <p:nvPr/>
-        </p:nvSpPr>
-        <p:spPr>
-          <a:xfrm>
-            <a:off x="658368" y="4626864"/>
-            <a:ext cx="3046506" cy="548640"/>
-          </a:xfrm>
-          <a:prstGeom prst="rect">
-            <a:avLst/>
-          </a:prstGeom>
-          <a:noFill/>
-        </p:spPr>
-        <p:txBody>
-          <a:bodyPr wrap="square" lIns="22860" rIns="22860" tIns="22860" bIns="13716" anchor="t">
-            <a:spAutoFit/>
-          </a:bodyPr>
-          <a:lstStyle/>
-          <a:p>
-            <a:pPr algn="l">
-              <a:lnSpc>
-                <a:spcPct val="110000"/>
-              </a:lnSpc>
-              <a:spcAft>
-                <a:spcPts val="0"/>
-              </a:spcAft>
-            </a:pPr>
-            <a:r>
-              <a:rPr sz="2400" b="1">
-                <a:solidFill>
-                  <a:srgbClr val="17324D"/>
-                </a:solidFill>
-                <a:latin typeface="DejaVu Sans"/>
-              </a:rPr>
-              <a:t>Total</a:t>
-            </a:r>
-          </a:p>
-        </p:txBody>
-      </p:sp>
-      <p:sp>
-        <p:nvSpPr>
-          <p:cNvPr id="27" name="TextBox 26"/>
-          <p:cNvSpPr txBox="1"/>
-          <p:nvPr/>
-        </p:nvSpPr>
-        <p:spPr>
-          <a:xfrm>
-            <a:off x="3878610" y="4626864"/>
-            <a:ext cx="1324051" cy="548640"/>
-          </a:xfrm>
-          <a:prstGeom prst="rect">
-            <a:avLst/>
-          </a:prstGeom>
-          <a:noFill/>
-        </p:spPr>
-        <p:txBody>
-          <a:bodyPr wrap="square" lIns="22860" rIns="22860" tIns="22860" bIns="13716" anchor="t">
-            <a:spAutoFit/>
-          </a:bodyPr>
-          <a:lstStyle/>
-          <a:p>
-            <a:pPr algn="l">
-              <a:lnSpc>
-                <a:spcPct val="110000"/>
-              </a:lnSpc>
-              <a:spcAft>
-                <a:spcPts val="0"/>
-              </a:spcAft>
-            </a:pPr>
-            <a:r>
-              <a:rPr sz="2400" b="0">
-                <a:solidFill>
-                  <a:srgbClr val="17324D"/>
-                </a:solidFill>
-                <a:latin typeface="DejaVu Sans"/>
-              </a:rPr>
-              <a:t>39</a:t>
-            </a:r>
-          </a:p>
-        </p:txBody>
-      </p:sp>
-      <p:sp>
-        <p:nvSpPr>
-          <p:cNvPr id="28" name="TextBox 27"/>
-          <p:cNvSpPr txBox="1"/>
-          <p:nvPr/>
-        </p:nvSpPr>
-        <p:spPr>
-          <a:xfrm>
-            <a:off x="5376397" y="4626864"/>
-            <a:ext cx="2597170" cy="548640"/>
-          </a:xfrm>
-          <a:prstGeom prst="rect">
-            <a:avLst/>
-          </a:prstGeom>
-          <a:noFill/>
-        </p:spPr>
-        <p:txBody>
-          <a:bodyPr wrap="square" lIns="22860" rIns="22860" tIns="22860" bIns="13716" anchor="t">
-            <a:spAutoFit/>
-          </a:bodyPr>
-          <a:lstStyle/>
-          <a:p>
-            <a:pPr algn="l">
-              <a:lnSpc>
-                <a:spcPct val="110000"/>
-              </a:lnSpc>
-              <a:spcAft>
-                <a:spcPts val="0"/>
-              </a:spcAft>
-            </a:pPr>
-            <a:r>
-              <a:rPr sz="2400" b="0">
-                <a:solidFill>
-                  <a:srgbClr val="17324D"/>
-                </a:solidFill>
-                <a:latin typeface="DejaVu Sans"/>
-              </a:rPr>
-              <a:t>14</a:t>
-            </a:r>
-          </a:p>
-        </p:txBody>
-      </p:sp>
-      <p:sp>
-        <p:nvSpPr>
-          <p:cNvPr id="29" name="Rounded Rectangle 28"/>
-          <p:cNvSpPr/>
-          <p:nvPr/>
-        </p:nvSpPr>
-        <p:spPr>
-          <a:xfrm>
-            <a:off x="8412480" y="1874519"/>
-            <a:ext cx="3209544" cy="3337560"/>
-          </a:xfrm>
-          <a:prstGeom prst="roundRect">
-            <a:avLst>
-              <a:gd name="adj" fmla="val 8000"/>
-            </a:avLst>
-          </a:prstGeom>
-          <a:solidFill>
-            <a:srgbClr val="EDF5F6"/>
-          </a:solidFill>
-          <a:ln>
-            <a:noFill/>
-          </a:ln>
-        </p:spPr>
-        <p:style>
-          <a:lnRef idx="1">
-            <a:schemeClr val="accent1"/>
-          </a:lnRef>
-          <a:fillRef idx="3">
-            <a:schemeClr val="accent1"/>
-          </a:fillRef>
-          <a:effectRef idx="2">
-            <a:schemeClr val="accent1"/>
-          </a:effectRef>
-          <a:fontRef idx="minor">
-            <a:schemeClr val="lt1"/>
-          </a:fontRef>
-        </p:style>
-        <p:txBody>
-          <a:bodyPr rtlCol="0" anchor="ctr"/>
-          <a:lstStyle/>
-          <a:p>
-            <a:pPr algn="ctr"/>
-          </a:p>
-        </p:txBody>
-      </p:sp>
-      <p:sp>
-        <p:nvSpPr>
-          <p:cNvPr id="30" name="TextBox 29"/>
-          <p:cNvSpPr txBox="1"/>
-          <p:nvPr/>
-        </p:nvSpPr>
-        <p:spPr>
-          <a:xfrm>
-            <a:off x="8586216" y="2103120"/>
-            <a:ext cx="2852928" cy="594360"/>
-          </a:xfrm>
-          <a:prstGeom prst="rect">
-            <a:avLst/>
-          </a:prstGeom>
-          <a:noFill/>
-        </p:spPr>
-        <p:txBody>
-          <a:bodyPr wrap="square" lIns="22860" rIns="22860" tIns="22860" bIns="13716" anchor="t">
-            <a:spAutoFit/>
-          </a:bodyPr>
-          <a:lstStyle/>
-          <a:p>
-            <a:pPr algn="l">
-              <a:lnSpc>
-                <a:spcPct val="110000"/>
-              </a:lnSpc>
-              <a:spcAft>
-                <a:spcPts val="0"/>
-              </a:spcAft>
-            </a:pPr>
-            <a:r>
-              <a:rPr sz="2400" b="1">
-                <a:solidFill>
-                  <a:srgbClr val="087F7A"/>
-                </a:solidFill>
-                <a:latin typeface="DejaVu Sans"/>
-              </a:rPr>
-              <a:t>Registro propio</a:t>
-            </a:r>
-          </a:p>
-        </p:txBody>
-      </p:sp>
-      <p:sp>
-        <p:nvSpPr>
-          <p:cNvPr id="31" name="TextBox 30"/>
-          <p:cNvSpPr txBox="1"/>
-          <p:nvPr/>
-        </p:nvSpPr>
-        <p:spPr>
-          <a:xfrm>
-            <a:off x="8586216" y="2980944"/>
-            <a:ext cx="2852928" cy="1975104"/>
-          </a:xfrm>
-          <a:prstGeom prst="rect">
-            <a:avLst/>
-          </a:prstGeom>
-          <a:noFill/>
-        </p:spPr>
-        <p:txBody>
-          <a:bodyPr wrap="square" lIns="22860" rIns="22860" tIns="22860" bIns="13716" anchor="t">
-            <a:spAutoFit/>
-          </a:bodyPr>
-          <a:lstStyle/>
-          <a:p>
-            <a:pPr algn="l">
-              <a:lnSpc>
-                <a:spcPct val="110000"/>
-              </a:lnSpc>
-              <a:spcAft>
-                <a:spcPts val="0"/>
-              </a:spcAft>
-            </a:pPr>
-            <a:r>
-              <a:rPr sz="2400" b="0">
-                <a:solidFill>
-                  <a:srgbClr val="17324D"/>
-                </a:solidFill>
-                <a:latin typeface="DejaVu Sans"/>
-              </a:rPr>
-              <a:t>Los 25 rechazos del portal no tienen desglose AT / AI / EP.</a:t>
-            </a:r>
-          </a:p>
-        </p:txBody>
-      </p:sp>
-      <p:sp>
-        <p:nvSpPr>
-          <p:cNvPr id="32" name="Rounded Rectangle 31"/>
-          <p:cNvSpPr/>
-          <p:nvPr/>
-        </p:nvSpPr>
-        <p:spPr>
-          <a:xfrm>
-            <a:off x="566928" y="5623560"/>
-            <a:ext cx="11064240" cy="630936"/>
-          </a:xfrm>
-          <a:prstGeom prst="roundRect">
-            <a:avLst>
-              <a:gd name="adj" fmla="val 8000"/>
-            </a:avLst>
-          </a:prstGeom>
-          <a:solidFill>
-            <a:srgbClr val="EDF5F6"/>
-          </a:solidFill>
-          <a:ln>
-            <a:noFill/>
-          </a:ln>
-        </p:spPr>
-        <p:style>
-          <a:lnRef idx="1">
-            <a:schemeClr val="accent1"/>
-          </a:lnRef>
-          <a:fillRef idx="3">
-            <a:schemeClr val="accent1"/>
-          </a:fillRef>
-          <a:effectRef idx="2">
-            <a:schemeClr val="accent1"/>
-          </a:effectRef>
-          <a:fontRef idx="minor">
-            <a:schemeClr val="lt1"/>
-          </a:fontRef>
-        </p:style>
-        <p:txBody>
-          <a:bodyPr rtlCol="0" anchor="ctr"/>
-          <a:lstStyle/>
-          <a:p>
-            <a:pPr algn="ctr"/>
-          </a:p>
-        </p:txBody>
-      </p:sp>
-      <p:sp>
-        <p:nvSpPr>
-          <p:cNvPr id="33" name="Rectangle 32"/>
-          <p:cNvSpPr/>
-          <p:nvPr/>
-        </p:nvSpPr>
-        <p:spPr>
-          <a:xfrm>
-            <a:off x="566928" y="5623560"/>
-            <a:ext cx="54864" cy="630936"/>
-          </a:xfrm>
-          <a:prstGeom prst="rect">
-            <a:avLst/>
-          </a:prstGeom>
-          <a:solidFill>
-            <a:srgbClr val="087F7A"/>
-          </a:solidFill>
-          <a:ln>
-            <a:noFill/>
-          </a:ln>
-        </p:spPr>
-        <p:style>
-          <a:lnRef idx="1">
-            <a:schemeClr val="accent1"/>
-          </a:lnRef>
-          <a:fillRef idx="3">
-            <a:schemeClr val="accent1"/>
-          </a:fillRef>
-          <a:effectRef idx="2">
-            <a:schemeClr val="accent1"/>
-          </a:effectRef>
-          <a:fontRef idx="minor">
-            <a:schemeClr val="lt1"/>
-          </a:fontRef>
-        </p:style>
-        <p:txBody>
-          <a:bodyPr rtlCol="0" anchor="ctr"/>
-          <a:lstStyle/>
-          <a:p>
-            <a:pPr algn="ctr"/>
-          </a:p>
-        </p:txBody>
-      </p:sp>
-      <p:sp>
-        <p:nvSpPr>
-          <p:cNvPr id="34" name="TextBox 33"/>
-          <p:cNvSpPr txBox="1"/>
-          <p:nvPr/>
-        </p:nvSpPr>
-        <p:spPr>
-          <a:xfrm>
-            <a:off x="713232" y="5696712"/>
-            <a:ext cx="10725912" cy="512063"/>
-          </a:xfrm>
-          <a:prstGeom prst="rect">
-            <a:avLst/>
-          </a:prstGeom>
-          <a:noFill/>
-        </p:spPr>
-        <p:txBody>
-          <a:bodyPr wrap="square" lIns="22860" rIns="22860" tIns="22860" bIns="13716" anchor="t">
-            <a:spAutoFit/>
-          </a:bodyPr>
-          <a:lstStyle/>
-          <a:p>
-            <a:pPr algn="l">
-              <a:lnSpc>
-                <a:spcPct val="110000"/>
-              </a:lnSpc>
-              <a:spcAft>
-                <a:spcPts val="0"/>
-              </a:spcAft>
-            </a:pPr>
-            <a:r>
-              <a:rPr sz="1850" b="0">
-                <a:solidFill>
-                  <a:srgbClr val="17324D"/>
-                </a:solidFill>
-                <a:latin typeface="DejaVu Sans"/>
-              </a:rPr>
-              <a:t>La falta de mención de rechazo no confirma aceptación.</a:t>
-            </a:r>
-          </a:p>
-        </p:txBody>
-      </p:sp>
-    </p:spTree>
-  </p:cSld>
-  <p:clrMapOvr>
-    <a:masterClrMapping/>
-  </p:clrMapOvr>
-</p:sld>
-</file>
-
-<file path=ppt/slides/slide12.xml><?xml version="1.0" encoding="utf-8"?>
-<p:sld xmlns:a="http://schemas.openxmlformats.org/drawingml/2006/main" xmlns:p="http://schemas.openxmlformats.org/presentationml/2006/main" xmlns:r="http://schemas.openxmlformats.org/officeDocument/2006/relationships">
-  <p:cSld>
-    <p:bg>
-      <p:bgPr>
-        <a:solidFill>
-          <a:srgbClr val="FFFFFF"/>
-        </a:solidFill>
-        <a:effectLst/>
-      </p:bgPr>
-    </p:bg>
-    <p:spTree>
-      <p:nvGrpSpPr>
-        <p:cNvPr id="1" name=""/>
-        <p:cNvGrpSpPr/>
-        <p:nvPr/>
-      </p:nvGrpSpPr>
-      <p:grpSpPr/>
-      <p:sp>
-        <p:nvSpPr>
-          <p:cNvPr id="2" name="Rectangle 1"/>
-          <p:cNvSpPr/>
-          <p:nvPr/>
-        </p:nvSpPr>
-        <p:spPr>
-          <a:xfrm>
-            <a:off x="0" y="0"/>
-            <a:ext cx="12191999" cy="109728"/>
-          </a:xfrm>
-          <a:prstGeom prst="rect">
-            <a:avLst/>
-          </a:prstGeom>
-          <a:solidFill>
-            <a:srgbClr val="087F7A"/>
-          </a:solidFill>
-          <a:ln>
-            <a:noFill/>
-          </a:ln>
-        </p:spPr>
-        <p:style>
-          <a:lnRef idx="1">
-            <a:schemeClr val="accent1"/>
-          </a:lnRef>
-          <a:fillRef idx="3">
-            <a:schemeClr val="accent1"/>
-          </a:fillRef>
-          <a:effectRef idx="2">
-            <a:schemeClr val="accent1"/>
-          </a:effectRef>
-          <a:fontRef idx="minor">
-            <a:schemeClr val="lt1"/>
-          </a:fontRef>
-        </p:style>
-        <p:txBody>
-          <a:bodyPr rtlCol="0" anchor="ctr"/>
-          <a:lstStyle/>
-          <a:p>
-            <a:pPr algn="ctr"/>
-          </a:p>
-        </p:txBody>
-      </p:sp>
-      <p:sp>
-        <p:nvSpPr>
-          <p:cNvPr id="3" name="TextBox 2"/>
-          <p:cNvSpPr txBox="1"/>
-          <p:nvPr/>
-        </p:nvSpPr>
-        <p:spPr>
-          <a:xfrm>
-            <a:off x="566928" y="219456"/>
-            <a:ext cx="11064240" cy="292608"/>
-          </a:xfrm>
-          <a:prstGeom prst="rect">
-            <a:avLst/>
-          </a:prstGeom>
-          <a:noFill/>
-        </p:spPr>
-        <p:txBody>
-          <a:bodyPr wrap="square" lIns="22860" rIns="22860" tIns="22860" bIns="13716" anchor="t">
-            <a:spAutoFit/>
-          </a:bodyPr>
-          <a:lstStyle/>
-          <a:p>
-            <a:pPr algn="l">
-              <a:lnSpc>
-                <a:spcPct val="110000"/>
-              </a:lnSpc>
-              <a:spcAft>
-                <a:spcPts val="0"/>
-              </a:spcAft>
-            </a:pPr>
-            <a:r>
-              <a:rPr sz="1400" b="1">
-                <a:solidFill>
-                  <a:srgbClr val="087F7A"/>
-                </a:solidFill>
-                <a:latin typeface="DejaVu Sans"/>
-              </a:rPr>
-              <a:t>SERVICIO MÉDICO  /  TANDANOR</a:t>
-            </a:r>
-          </a:p>
-        </p:txBody>
-      </p:sp>
-      <p:sp>
-        <p:nvSpPr>
-          <p:cNvPr id="4" name="TextBox 3"/>
-          <p:cNvSpPr txBox="1"/>
-          <p:nvPr/>
-        </p:nvSpPr>
-        <p:spPr>
-          <a:xfrm>
-            <a:off x="566928" y="694944"/>
-            <a:ext cx="11064240" cy="502920"/>
-          </a:xfrm>
-          <a:prstGeom prst="rect">
-            <a:avLst/>
-          </a:prstGeom>
-          <a:noFill/>
-        </p:spPr>
-        <p:txBody>
-          <a:bodyPr wrap="square" lIns="22860" rIns="22860" tIns="22860" bIns="13716" anchor="t">
-            <a:spAutoFit/>
-          </a:bodyPr>
-          <a:lstStyle/>
-          <a:p>
-            <a:pPr algn="l">
-              <a:lnSpc>
-                <a:spcPct val="110000"/>
-              </a:lnSpc>
-              <a:spcAft>
-                <a:spcPts val="0"/>
-              </a:spcAft>
-            </a:pPr>
-            <a:r>
-              <a:rPr sz="2900" b="1">
-                <a:solidFill>
-                  <a:srgbClr val="17324D"/>
-                </a:solidFill>
-                <a:latin typeface="DejaVu Sans"/>
-              </a:rPr>
-              <a:t>Cómo interpretar el cruce con la ART</a:t>
-            </a:r>
-          </a:p>
-        </p:txBody>
-      </p:sp>
-      <p:sp>
-        <p:nvSpPr>
-          <p:cNvPr id="5" name="TextBox 4"/>
-          <p:cNvSpPr txBox="1"/>
-          <p:nvPr/>
-        </p:nvSpPr>
-        <p:spPr>
-          <a:xfrm>
-            <a:off x="566928" y="1271016"/>
-            <a:ext cx="11064240" cy="384048"/>
-          </a:xfrm>
-          <a:prstGeom prst="rect">
-            <a:avLst/>
-          </a:prstGeom>
-          <a:noFill/>
-        </p:spPr>
-        <p:txBody>
-          <a:bodyPr wrap="square" lIns="22860" rIns="22860" tIns="22860" bIns="13716" anchor="t">
-            <a:spAutoFit/>
-          </a:bodyPr>
-          <a:lstStyle/>
-          <a:p>
-            <a:pPr algn="l">
-              <a:lnSpc>
-                <a:spcPct val="110000"/>
-              </a:lnSpc>
-              <a:spcAft>
-                <a:spcPts val="0"/>
-              </a:spcAft>
-            </a:pPr>
-            <a:r>
-              <a:rPr sz="1600" b="0">
-                <a:solidFill>
-                  <a:srgbClr val="586B7C"/>
-                </a:solidFill>
-                <a:latin typeface="DejaVu Sans"/>
-              </a:rPr>
-              <a:t>Dos fuentes describen universos y fechas diferentes</a:t>
-            </a:r>
-          </a:p>
-        </p:txBody>
-      </p:sp>
-      <p:sp>
-        <p:nvSpPr>
-          <p:cNvPr id="6" name="Rectangle 5"/>
-          <p:cNvSpPr/>
-          <p:nvPr/>
-        </p:nvSpPr>
-        <p:spPr>
-          <a:xfrm>
-            <a:off x="566928" y="6364224"/>
-            <a:ext cx="11064240" cy="11887"/>
-          </a:xfrm>
-          <a:prstGeom prst="rect">
-            <a:avLst/>
-          </a:prstGeom>
-          <a:solidFill>
-            <a:srgbClr val="D6E2E8"/>
-          </a:solidFill>
-          <a:ln>
-            <a:noFill/>
-          </a:ln>
-        </p:spPr>
-        <p:style>
-          <a:lnRef idx="1">
-            <a:schemeClr val="accent1"/>
-          </a:lnRef>
-          <a:fillRef idx="3">
-            <a:schemeClr val="accent1"/>
-          </a:fillRef>
-          <a:effectRef idx="2">
-            <a:schemeClr val="accent1"/>
-          </a:effectRef>
-          <a:fontRef idx="minor">
-            <a:schemeClr val="lt1"/>
-          </a:fontRef>
-        </p:style>
-        <p:txBody>
-          <a:bodyPr rtlCol="0" anchor="ctr"/>
-          <a:lstStyle/>
-          <a:p>
-            <a:pPr algn="ctr"/>
-          </a:p>
-        </p:txBody>
-      </p:sp>
-      <p:sp>
-        <p:nvSpPr>
-          <p:cNvPr id="7" name="TextBox 6"/>
-          <p:cNvSpPr txBox="1"/>
-          <p:nvPr/>
-        </p:nvSpPr>
-        <p:spPr>
-          <a:xfrm>
-            <a:off x="566928" y="6473952"/>
-            <a:ext cx="9875520" cy="201168"/>
-          </a:xfrm>
-          <a:prstGeom prst="rect">
-            <a:avLst/>
-          </a:prstGeom>
-          <a:noFill/>
-        </p:spPr>
-        <p:txBody>
-          <a:bodyPr wrap="square" lIns="22860" rIns="22860" tIns="22860" bIns="13716" anchor="t">
-            <a:spAutoFit/>
-          </a:bodyPr>
-          <a:lstStyle/>
-          <a:p>
-            <a:pPr algn="l">
-              <a:lnSpc>
-                <a:spcPct val="110000"/>
-              </a:lnSpc>
-              <a:spcAft>
-                <a:spcPts val="0"/>
-              </a:spcAft>
-            </a:pPr>
-            <a:r>
-              <a:rPr sz="1150" b="0">
-                <a:solidFill>
-                  <a:srgbClr val="586B7C"/>
-                </a:solidFill>
-                <a:latin typeface="DejaVu Sans"/>
-              </a:rPr>
-              <a:t>Siniestralidad · Enero–septiembre  ·  8 de octubre de 2026  ·  Planilla actualizada / Provincia ART · págs. 1 y 3</a:t>
-            </a:r>
-          </a:p>
-        </p:txBody>
-      </p:sp>
-      <p:sp>
-        <p:nvSpPr>
-          <p:cNvPr id="8" name="TextBox 7"/>
-          <p:cNvSpPr txBox="1"/>
-          <p:nvPr/>
-        </p:nvSpPr>
-        <p:spPr>
-          <a:xfrm>
-            <a:off x="11045952" y="6455664"/>
-            <a:ext cx="530352" cy="228600"/>
-          </a:xfrm>
-          <a:prstGeom prst="rect">
-            <a:avLst/>
-          </a:prstGeom>
-          <a:noFill/>
-        </p:spPr>
-        <p:txBody>
-          <a:bodyPr wrap="square" lIns="22860" rIns="22860" tIns="22860" bIns="13716" anchor="t">
-            <a:spAutoFit/>
-          </a:bodyPr>
-          <a:lstStyle/>
-          <a:p>
-            <a:pPr algn="r">
-              <a:lnSpc>
-                <a:spcPct val="110000"/>
-              </a:lnSpc>
-              <a:spcAft>
-                <a:spcPts val="0"/>
-              </a:spcAft>
-            </a:pPr>
-            <a:r>
-              <a:rPr sz="1200" b="1">
-                <a:solidFill>
-                  <a:srgbClr val="087F7A"/>
-                </a:solidFill>
-                <a:latin typeface="DejaVu Sans"/>
-              </a:rPr>
-              <a:t>12</a:t>
-            </a:r>
-          </a:p>
-        </p:txBody>
-      </p:sp>
-      <p:sp>
-        <p:nvSpPr>
-          <p:cNvPr id="9" name="Rectangle 8"/>
-          <p:cNvSpPr/>
-          <p:nvPr/>
-        </p:nvSpPr>
-        <p:spPr>
-          <a:xfrm>
-            <a:off x="566928" y="1847088"/>
-            <a:ext cx="11064240" cy="521207"/>
-          </a:xfrm>
-          <a:prstGeom prst="rect">
-            <a:avLst/>
-          </a:prstGeom>
-          <a:solidFill>
-            <a:srgbClr val="17324D"/>
-          </a:solidFill>
-          <a:ln>
-            <a:noFill/>
-          </a:ln>
-        </p:spPr>
-        <p:style>
-          <a:lnRef idx="1">
-            <a:schemeClr val="accent1"/>
-          </a:lnRef>
-          <a:fillRef idx="3">
-            <a:schemeClr val="accent1"/>
-          </a:fillRef>
-          <a:effectRef idx="2">
-            <a:schemeClr val="accent1"/>
-          </a:effectRef>
-          <a:fontRef idx="minor">
-            <a:schemeClr val="lt1"/>
-          </a:fontRef>
-        </p:style>
-        <p:txBody>
-          <a:bodyPr rtlCol="0" anchor="ctr"/>
-          <a:lstStyle/>
-          <a:p>
-            <a:pPr algn="ctr"/>
-          </a:p>
-        </p:txBody>
-      </p:sp>
-      <p:sp>
-        <p:nvSpPr>
-          <p:cNvPr id="10" name="TextBox 9"/>
-          <p:cNvSpPr txBox="1"/>
-          <p:nvPr/>
-        </p:nvSpPr>
-        <p:spPr>
-          <a:xfrm>
-            <a:off x="658368" y="1929384"/>
-            <a:ext cx="6907377" cy="402335"/>
-          </a:xfrm>
-          <a:prstGeom prst="rect">
-            <a:avLst/>
-          </a:prstGeom>
-          <a:noFill/>
-        </p:spPr>
-        <p:txBody>
-          <a:bodyPr wrap="square" lIns="22860" rIns="22860" tIns="22860" bIns="13716" anchor="t">
-            <a:spAutoFit/>
-          </a:bodyPr>
-          <a:lstStyle/>
-          <a:p>
-            <a:pPr algn="l">
-              <a:lnSpc>
-                <a:spcPct val="110000"/>
-              </a:lnSpc>
-              <a:spcAft>
-                <a:spcPts val="0"/>
-              </a:spcAft>
-            </a:pPr>
-            <a:r>
-              <a:rPr sz="2400" b="1">
-                <a:solidFill>
-                  <a:srgbClr val="FFFFFF"/>
-                </a:solidFill>
-                <a:latin typeface="DejaVu Sans"/>
-              </a:rPr>
-              <a:t>Fuente / indicador</a:t>
-            </a:r>
-          </a:p>
-        </p:txBody>
-      </p:sp>
-      <p:sp>
-        <p:nvSpPr>
-          <p:cNvPr id="11" name="TextBox 10"/>
-          <p:cNvSpPr txBox="1"/>
-          <p:nvPr/>
-        </p:nvSpPr>
-        <p:spPr>
-          <a:xfrm>
-            <a:off x="7739481" y="1929384"/>
-            <a:ext cx="1817827" cy="402335"/>
-          </a:xfrm>
-          <a:prstGeom prst="rect">
-            <a:avLst/>
-          </a:prstGeom>
-          <a:noFill/>
-        </p:spPr>
-        <p:txBody>
-          <a:bodyPr wrap="square" lIns="22860" rIns="22860" tIns="22860" bIns="13716" anchor="t">
-            <a:spAutoFit/>
-          </a:bodyPr>
-          <a:lstStyle/>
-          <a:p>
-            <a:pPr algn="l">
-              <a:lnSpc>
-                <a:spcPct val="110000"/>
-              </a:lnSpc>
-              <a:spcAft>
-                <a:spcPts val="0"/>
-              </a:spcAft>
-            </a:pPr>
-            <a:r>
-              <a:rPr sz="2400" b="1">
-                <a:solidFill>
-                  <a:srgbClr val="FFFFFF"/>
-                </a:solidFill>
-                <a:latin typeface="DejaVu Sans"/>
-              </a:rPr>
-              <a:t>2025</a:t>
-            </a:r>
-          </a:p>
-        </p:txBody>
-      </p:sp>
-      <p:sp>
-        <p:nvSpPr>
-          <p:cNvPr id="12" name="TextBox 11"/>
-          <p:cNvSpPr txBox="1"/>
-          <p:nvPr/>
-        </p:nvSpPr>
-        <p:spPr>
-          <a:xfrm>
-            <a:off x="9731044" y="1929384"/>
-            <a:ext cx="1817827" cy="402335"/>
-          </a:xfrm>
-          <a:prstGeom prst="rect">
-            <a:avLst/>
-          </a:prstGeom>
-          <a:noFill/>
-        </p:spPr>
-        <p:txBody>
-          <a:bodyPr wrap="square" lIns="22860" rIns="22860" tIns="22860" bIns="13716" anchor="t">
-            <a:spAutoFit/>
-          </a:bodyPr>
-          <a:lstStyle/>
-          <a:p>
-            <a:pPr algn="l">
-              <a:lnSpc>
-                <a:spcPct val="110000"/>
-              </a:lnSpc>
-              <a:spcAft>
-                <a:spcPts val="0"/>
-              </a:spcAft>
-            </a:pPr>
-            <a:r>
-              <a:rPr sz="2400" b="1">
-                <a:solidFill>
-                  <a:srgbClr val="FFFFFF"/>
-                </a:solidFill>
-                <a:latin typeface="DejaVu Sans"/>
-              </a:rPr>
-              <a:t>2026</a:t>
-            </a:r>
-          </a:p>
-        </p:txBody>
-      </p:sp>
-      <p:sp>
-        <p:nvSpPr>
-          <p:cNvPr id="13" name="Rectangle 12"/>
-          <p:cNvSpPr/>
-          <p:nvPr/>
-        </p:nvSpPr>
-        <p:spPr>
-          <a:xfrm>
-            <a:off x="566928" y="2368296"/>
-            <a:ext cx="11064240" cy="521207"/>
-          </a:xfrm>
-          <a:prstGeom prst="rect">
-            <a:avLst/>
-          </a:prstGeom>
-          <a:solidFill>
-            <a:srgbClr val="F3F6F8"/>
-          </a:solidFill>
-          <a:ln>
-            <a:noFill/>
-          </a:ln>
-        </p:spPr>
-        <p:style>
-          <a:lnRef idx="1">
-            <a:schemeClr val="accent1"/>
-          </a:lnRef>
-          <a:fillRef idx="3">
-            <a:schemeClr val="accent1"/>
-          </a:fillRef>
-          <a:effectRef idx="2">
-            <a:schemeClr val="accent1"/>
-          </a:effectRef>
-          <a:fontRef idx="minor">
-            <a:schemeClr val="lt1"/>
-          </a:fontRef>
-        </p:style>
-        <p:txBody>
-          <a:bodyPr rtlCol="0" anchor="ctr"/>
-          <a:lstStyle/>
-          <a:p>
-            <a:pPr algn="ctr"/>
-          </a:p>
-        </p:txBody>
-      </p:sp>
-      <p:sp>
-        <p:nvSpPr>
-          <p:cNvPr id="14" name="TextBox 13"/>
-          <p:cNvSpPr txBox="1"/>
-          <p:nvPr/>
-        </p:nvSpPr>
-        <p:spPr>
-          <a:xfrm>
-            <a:off x="658368" y="2450591"/>
-            <a:ext cx="6907377" cy="402335"/>
-          </a:xfrm>
-          <a:prstGeom prst="rect">
-            <a:avLst/>
-          </a:prstGeom>
-          <a:noFill/>
-        </p:spPr>
-        <p:txBody>
-          <a:bodyPr wrap="square" lIns="22860" rIns="22860" tIns="22860" bIns="13716" anchor="t">
-            <a:spAutoFit/>
-          </a:bodyPr>
-          <a:lstStyle/>
-          <a:p>
-            <a:pPr algn="l">
-              <a:lnSpc>
-                <a:spcPct val="110000"/>
-              </a:lnSpc>
-              <a:spcAft>
-                <a:spcPts val="0"/>
-              </a:spcAft>
-            </a:pPr>
-            <a:r>
-              <a:rPr sz="2400" b="1">
-                <a:solidFill>
-                  <a:srgbClr val="17324D"/>
-                </a:solidFill>
-                <a:latin typeface="DejaVu Sans"/>
-              </a:rPr>
-              <a:t>Portal · Denuncias</a:t>
-            </a:r>
-          </a:p>
-        </p:txBody>
-      </p:sp>
-      <p:sp>
-        <p:nvSpPr>
-          <p:cNvPr id="15" name="TextBox 14"/>
-          <p:cNvSpPr txBox="1"/>
-          <p:nvPr/>
-        </p:nvSpPr>
-        <p:spPr>
-          <a:xfrm>
-            <a:off x="7739481" y="2450591"/>
-            <a:ext cx="1817827" cy="402335"/>
-          </a:xfrm>
-          <a:prstGeom prst="rect">
-            <a:avLst/>
-          </a:prstGeom>
-          <a:noFill/>
-        </p:spPr>
-        <p:txBody>
-          <a:bodyPr wrap="square" lIns="22860" rIns="22860" tIns="22860" bIns="13716" anchor="t">
-            <a:spAutoFit/>
-          </a:bodyPr>
-          <a:lstStyle/>
-          <a:p>
-            <a:pPr algn="l">
-              <a:lnSpc>
-                <a:spcPct val="110000"/>
-              </a:lnSpc>
-              <a:spcAft>
-                <a:spcPts val="0"/>
-              </a:spcAft>
-            </a:pPr>
-            <a:r>
-              <a:rPr sz="2400" b="0">
-                <a:solidFill>
-                  <a:srgbClr val="17324D"/>
-                </a:solidFill>
-                <a:latin typeface="DejaVu Sans"/>
-              </a:rPr>
-              <a:t>82</a:t>
-            </a:r>
-          </a:p>
-        </p:txBody>
-      </p:sp>
-      <p:sp>
-        <p:nvSpPr>
-          <p:cNvPr id="16" name="TextBox 15"/>
-          <p:cNvSpPr txBox="1"/>
-          <p:nvPr/>
-        </p:nvSpPr>
-        <p:spPr>
-          <a:xfrm>
-            <a:off x="9731044" y="2450591"/>
-            <a:ext cx="1817827" cy="402335"/>
-          </a:xfrm>
-          <a:prstGeom prst="rect">
-            <a:avLst/>
-          </a:prstGeom>
-          <a:noFill/>
-        </p:spPr>
-        <p:txBody>
-          <a:bodyPr wrap="square" lIns="22860" rIns="22860" tIns="22860" bIns="13716" anchor="t">
-            <a:spAutoFit/>
-          </a:bodyPr>
-          <a:lstStyle/>
-          <a:p>
-            <a:pPr algn="l">
-              <a:lnSpc>
-                <a:spcPct val="110000"/>
-              </a:lnSpc>
-              <a:spcAft>
-                <a:spcPts val="0"/>
-              </a:spcAft>
-            </a:pPr>
-            <a:r>
-              <a:rPr sz="2400" b="0">
-                <a:solidFill>
-                  <a:srgbClr val="17324D"/>
-                </a:solidFill>
-                <a:latin typeface="DejaVu Sans"/>
-              </a:rPr>
-              <a:t>56</a:t>
-            </a:r>
-          </a:p>
-        </p:txBody>
-      </p:sp>
-      <p:sp>
-        <p:nvSpPr>
-          <p:cNvPr id="17" name="Rectangle 16"/>
-          <p:cNvSpPr/>
-          <p:nvPr/>
-        </p:nvSpPr>
-        <p:spPr>
-          <a:xfrm>
-            <a:off x="566928" y="2889504"/>
-            <a:ext cx="11064240" cy="521207"/>
-          </a:xfrm>
-          <a:prstGeom prst="rect">
-            <a:avLst/>
-          </a:prstGeom>
-          <a:solidFill>
-            <a:srgbClr val="FFFFFF"/>
-          </a:solidFill>
-          <a:ln>
-            <a:noFill/>
-          </a:ln>
-        </p:spPr>
-        <p:style>
-          <a:lnRef idx="1">
-            <a:schemeClr val="accent1"/>
-          </a:lnRef>
-          <a:fillRef idx="3">
-            <a:schemeClr val="accent1"/>
-          </a:fillRef>
-          <a:effectRef idx="2">
-            <a:schemeClr val="accent1"/>
-          </a:effectRef>
-          <a:fontRef idx="minor">
-            <a:schemeClr val="lt1"/>
-          </a:fontRef>
-        </p:style>
-        <p:txBody>
-          <a:bodyPr rtlCol="0" anchor="ctr"/>
-          <a:lstStyle/>
-          <a:p>
-            <a:pPr algn="ctr"/>
-          </a:p>
-        </p:txBody>
-      </p:sp>
-      <p:sp>
-        <p:nvSpPr>
-          <p:cNvPr id="18" name="TextBox 17"/>
-          <p:cNvSpPr txBox="1"/>
-          <p:nvPr/>
-        </p:nvSpPr>
-        <p:spPr>
-          <a:xfrm>
-            <a:off x="658368" y="2971800"/>
-            <a:ext cx="6907377" cy="402335"/>
-          </a:xfrm>
-          <a:prstGeom prst="rect">
-            <a:avLst/>
-          </a:prstGeom>
-          <a:noFill/>
-        </p:spPr>
-        <p:txBody>
-          <a:bodyPr wrap="square" lIns="22860" rIns="22860" tIns="22860" bIns="13716" anchor="t">
-            <a:spAutoFit/>
-          </a:bodyPr>
-          <a:lstStyle/>
-          <a:p>
-            <a:pPr algn="l">
-              <a:lnSpc>
-                <a:spcPct val="110000"/>
-              </a:lnSpc>
-              <a:spcAft>
-                <a:spcPts val="0"/>
-              </a:spcAft>
-            </a:pPr>
-            <a:r>
-              <a:rPr sz="2400" b="1">
-                <a:solidFill>
-                  <a:srgbClr val="17324D"/>
-                </a:solidFill>
-                <a:latin typeface="DejaVu Sans"/>
-              </a:rPr>
-              <a:t>Portal · Rechazos</a:t>
-            </a:r>
-          </a:p>
-        </p:txBody>
-      </p:sp>
-      <p:sp>
-        <p:nvSpPr>
-          <p:cNvPr id="19" name="TextBox 18"/>
-          <p:cNvSpPr txBox="1"/>
-          <p:nvPr/>
-        </p:nvSpPr>
-        <p:spPr>
-          <a:xfrm>
-            <a:off x="7739481" y="2971800"/>
-            <a:ext cx="1817827" cy="402335"/>
-          </a:xfrm>
-          <a:prstGeom prst="rect">
-            <a:avLst/>
-          </a:prstGeom>
-          <a:noFill/>
-        </p:spPr>
-        <p:txBody>
-          <a:bodyPr wrap="square" lIns="22860" rIns="22860" tIns="22860" bIns="13716" anchor="t">
-            <a:spAutoFit/>
-          </a:bodyPr>
-          <a:lstStyle/>
-          <a:p>
-            <a:pPr algn="l">
-              <a:lnSpc>
-                <a:spcPct val="110000"/>
-              </a:lnSpc>
-              <a:spcAft>
-                <a:spcPts val="0"/>
-              </a:spcAft>
-            </a:pPr>
-            <a:r>
-              <a:rPr sz="2400" b="0">
-                <a:solidFill>
-                  <a:srgbClr val="17324D"/>
-                </a:solidFill>
-                <a:latin typeface="DejaVu Sans"/>
-              </a:rPr>
-              <a:t>16</a:t>
-            </a:r>
-          </a:p>
-        </p:txBody>
-      </p:sp>
-      <p:sp>
-        <p:nvSpPr>
-          <p:cNvPr id="20" name="TextBox 19"/>
-          <p:cNvSpPr txBox="1"/>
-          <p:nvPr/>
-        </p:nvSpPr>
-        <p:spPr>
-          <a:xfrm>
-            <a:off x="9731044" y="2971800"/>
-            <a:ext cx="1817827" cy="402335"/>
-          </a:xfrm>
-          <a:prstGeom prst="rect">
-            <a:avLst/>
-          </a:prstGeom>
-          <a:noFill/>
-        </p:spPr>
-        <p:txBody>
-          <a:bodyPr wrap="square" lIns="22860" rIns="22860" tIns="22860" bIns="13716" anchor="t">
-            <a:spAutoFit/>
-          </a:bodyPr>
-          <a:lstStyle/>
-          <a:p>
-            <a:pPr algn="l">
-              <a:lnSpc>
-                <a:spcPct val="110000"/>
-              </a:lnSpc>
-              <a:spcAft>
-                <a:spcPts val="0"/>
-              </a:spcAft>
-            </a:pPr>
-            <a:r>
-              <a:rPr sz="2400" b="0">
-                <a:solidFill>
-                  <a:srgbClr val="17324D"/>
-                </a:solidFill>
-                <a:latin typeface="DejaVu Sans"/>
-              </a:rPr>
-              <a:t>25</a:t>
-            </a:r>
-          </a:p>
-        </p:txBody>
-      </p:sp>
-      <p:sp>
-        <p:nvSpPr>
-          <p:cNvPr id="21" name="Rectangle 20"/>
-          <p:cNvSpPr/>
-          <p:nvPr/>
-        </p:nvSpPr>
-        <p:spPr>
-          <a:xfrm>
-            <a:off x="566928" y="3410712"/>
-            <a:ext cx="11064240" cy="521207"/>
-          </a:xfrm>
-          <a:prstGeom prst="rect">
-            <a:avLst/>
-          </a:prstGeom>
-          <a:solidFill>
-            <a:srgbClr val="F3F6F8"/>
-          </a:solidFill>
-          <a:ln>
-            <a:noFill/>
-          </a:ln>
-        </p:spPr>
-        <p:style>
-          <a:lnRef idx="1">
-            <a:schemeClr val="accent1"/>
-          </a:lnRef>
-          <a:fillRef idx="3">
-            <a:schemeClr val="accent1"/>
-          </a:fillRef>
-          <a:effectRef idx="2">
-            <a:schemeClr val="accent1"/>
-          </a:effectRef>
-          <a:fontRef idx="minor">
-            <a:schemeClr val="lt1"/>
-          </a:fontRef>
-        </p:style>
-        <p:txBody>
-          <a:bodyPr rtlCol="0" anchor="ctr"/>
-          <a:lstStyle/>
-          <a:p>
-            <a:pPr algn="ctr"/>
-          </a:p>
-        </p:txBody>
-      </p:sp>
-      <p:sp>
-        <p:nvSpPr>
-          <p:cNvPr id="22" name="TextBox 21"/>
-          <p:cNvSpPr txBox="1"/>
-          <p:nvPr/>
-        </p:nvSpPr>
-        <p:spPr>
-          <a:xfrm>
-            <a:off x="658368" y="3493008"/>
-            <a:ext cx="6907377" cy="402335"/>
-          </a:xfrm>
-          <a:prstGeom prst="rect">
-            <a:avLst/>
-          </a:prstGeom>
-          <a:noFill/>
-        </p:spPr>
-        <p:txBody>
-          <a:bodyPr wrap="square" lIns="22860" rIns="22860" tIns="22860" bIns="13716" anchor="t">
-            <a:spAutoFit/>
-          </a:bodyPr>
-          <a:lstStyle/>
-          <a:p>
-            <a:pPr algn="l">
-              <a:lnSpc>
-                <a:spcPct val="110000"/>
-              </a:lnSpc>
-              <a:spcAft>
-                <a:spcPts val="0"/>
-              </a:spcAft>
-            </a:pPr>
-            <a:r>
-              <a:rPr sz="2400" b="1">
-                <a:solidFill>
-                  <a:srgbClr val="17324D"/>
-                </a:solidFill>
-                <a:latin typeface="DejaVu Sans"/>
-              </a:rPr>
-              <a:t>Portal · Casos graves</a:t>
-            </a:r>
-          </a:p>
-        </p:txBody>
-      </p:sp>
-      <p:sp>
-        <p:nvSpPr>
-          <p:cNvPr id="23" name="TextBox 22"/>
-          <p:cNvSpPr txBox="1"/>
-          <p:nvPr/>
-        </p:nvSpPr>
-        <p:spPr>
-          <a:xfrm>
-            <a:off x="7739481" y="3493008"/>
-            <a:ext cx="1817827" cy="402335"/>
-          </a:xfrm>
-          <a:prstGeom prst="rect">
-            <a:avLst/>
-          </a:prstGeom>
-          <a:noFill/>
-        </p:spPr>
-        <p:txBody>
-          <a:bodyPr wrap="square" lIns="22860" rIns="22860" tIns="22860" bIns="13716" anchor="t">
-            <a:spAutoFit/>
-          </a:bodyPr>
-          <a:lstStyle/>
-          <a:p>
-            <a:pPr algn="l">
-              <a:lnSpc>
-                <a:spcPct val="110000"/>
-              </a:lnSpc>
-              <a:spcAft>
-                <a:spcPts val="0"/>
-              </a:spcAft>
-            </a:pPr>
-            <a:r>
-              <a:rPr sz="2400" b="0">
-                <a:solidFill>
-                  <a:srgbClr val="17324D"/>
-                </a:solidFill>
-                <a:latin typeface="DejaVu Sans"/>
-              </a:rPr>
-              <a:t>2</a:t>
-            </a:r>
-          </a:p>
-        </p:txBody>
-      </p:sp>
-      <p:sp>
-        <p:nvSpPr>
-          <p:cNvPr id="24" name="TextBox 23"/>
-          <p:cNvSpPr txBox="1"/>
-          <p:nvPr/>
-        </p:nvSpPr>
-        <p:spPr>
-          <a:xfrm>
-            <a:off x="9731044" y="3493008"/>
-            <a:ext cx="1817827" cy="402335"/>
-          </a:xfrm>
-          <a:prstGeom prst="rect">
-            <a:avLst/>
-          </a:prstGeom>
-          <a:noFill/>
-        </p:spPr>
-        <p:txBody>
-          <a:bodyPr wrap="square" lIns="22860" rIns="22860" tIns="22860" bIns="13716" anchor="t">
-            <a:spAutoFit/>
-          </a:bodyPr>
-          <a:lstStyle/>
-          <a:p>
-            <a:pPr algn="l">
-              <a:lnSpc>
-                <a:spcPct val="110000"/>
-              </a:lnSpc>
-              <a:spcAft>
-                <a:spcPts val="0"/>
-              </a:spcAft>
-            </a:pPr>
-            <a:r>
-              <a:rPr sz="2400" b="0">
-                <a:solidFill>
-                  <a:srgbClr val="17324D"/>
-                </a:solidFill>
-                <a:latin typeface="DejaVu Sans"/>
-              </a:rPr>
-              <a:t>4</a:t>
-            </a:r>
-          </a:p>
-        </p:txBody>
-      </p:sp>
-      <p:sp>
-        <p:nvSpPr>
-          <p:cNvPr id="25" name="Rectangle 24"/>
-          <p:cNvSpPr/>
-          <p:nvPr/>
-        </p:nvSpPr>
-        <p:spPr>
-          <a:xfrm>
-            <a:off x="566928" y="3931920"/>
-            <a:ext cx="11064240" cy="521207"/>
-          </a:xfrm>
-          <a:prstGeom prst="rect">
-            <a:avLst/>
-          </a:prstGeom>
-          <a:solidFill>
-            <a:srgbClr val="FFFFFF"/>
-          </a:solidFill>
-          <a:ln>
-            <a:noFill/>
-          </a:ln>
-        </p:spPr>
-        <p:style>
-          <a:lnRef idx="1">
-            <a:schemeClr val="accent1"/>
-          </a:lnRef>
-          <a:fillRef idx="3">
-            <a:schemeClr val="accent1"/>
-          </a:fillRef>
-          <a:effectRef idx="2">
-            <a:schemeClr val="accent1"/>
-          </a:effectRef>
-          <a:fontRef idx="minor">
-            <a:schemeClr val="lt1"/>
-          </a:fontRef>
-        </p:style>
-        <p:txBody>
-          <a:bodyPr rtlCol="0" anchor="ctr"/>
-          <a:lstStyle/>
-          <a:p>
-            <a:pPr algn="ctr"/>
-          </a:p>
-        </p:txBody>
-      </p:sp>
-      <p:sp>
-        <p:nvSpPr>
-          <p:cNvPr id="26" name="TextBox 25"/>
-          <p:cNvSpPr txBox="1"/>
-          <p:nvPr/>
-        </p:nvSpPr>
-        <p:spPr>
-          <a:xfrm>
-            <a:off x="658368" y="4014215"/>
-            <a:ext cx="6907377" cy="402335"/>
-          </a:xfrm>
-          <a:prstGeom prst="rect">
-            <a:avLst/>
-          </a:prstGeom>
-          <a:noFill/>
-        </p:spPr>
-        <p:txBody>
-          <a:bodyPr wrap="square" lIns="22860" rIns="22860" tIns="22860" bIns="13716" anchor="t">
-            <a:spAutoFit/>
-          </a:bodyPr>
-          <a:lstStyle/>
-          <a:p>
-            <a:pPr algn="l">
-              <a:lnSpc>
-                <a:spcPct val="110000"/>
-              </a:lnSpc>
-              <a:spcAft>
-                <a:spcPts val="0"/>
-              </a:spcAft>
-            </a:pPr>
-            <a:r>
-              <a:rPr sz="2400" b="1">
-                <a:solidFill>
-                  <a:srgbClr val="17324D"/>
-                </a:solidFill>
-                <a:latin typeface="DejaVu Sans"/>
-              </a:rPr>
-              <a:t>Portal · Recaídas</a:t>
-            </a:r>
-          </a:p>
-        </p:txBody>
-      </p:sp>
-      <p:sp>
-        <p:nvSpPr>
-          <p:cNvPr id="27" name="TextBox 26"/>
-          <p:cNvSpPr txBox="1"/>
-          <p:nvPr/>
-        </p:nvSpPr>
-        <p:spPr>
-          <a:xfrm>
-            <a:off x="7739481" y="4014215"/>
-            <a:ext cx="1817827" cy="402335"/>
-          </a:xfrm>
-          <a:prstGeom prst="rect">
-            <a:avLst/>
-          </a:prstGeom>
-          <a:noFill/>
-        </p:spPr>
-        <p:txBody>
-          <a:bodyPr wrap="square" lIns="22860" rIns="22860" tIns="22860" bIns="13716" anchor="t">
-            <a:spAutoFit/>
-          </a:bodyPr>
-          <a:lstStyle/>
-          <a:p>
-            <a:pPr algn="l">
-              <a:lnSpc>
-                <a:spcPct val="110000"/>
-              </a:lnSpc>
-              <a:spcAft>
-                <a:spcPts val="0"/>
-              </a:spcAft>
-            </a:pPr>
-            <a:r>
-              <a:rPr sz="2400" b="0">
-                <a:solidFill>
-                  <a:srgbClr val="17324D"/>
-                </a:solidFill>
-                <a:latin typeface="DejaVu Sans"/>
-              </a:rPr>
-              <a:t>3</a:t>
-            </a:r>
-          </a:p>
-        </p:txBody>
-      </p:sp>
-      <p:sp>
-        <p:nvSpPr>
-          <p:cNvPr id="28" name="TextBox 27"/>
-          <p:cNvSpPr txBox="1"/>
-          <p:nvPr/>
-        </p:nvSpPr>
-        <p:spPr>
-          <a:xfrm>
-            <a:off x="9731044" y="4014215"/>
-            <a:ext cx="1817827" cy="402335"/>
-          </a:xfrm>
-          <a:prstGeom prst="rect">
-            <a:avLst/>
-          </a:prstGeom>
-          <a:noFill/>
-        </p:spPr>
-        <p:txBody>
-          <a:bodyPr wrap="square" lIns="22860" rIns="22860" tIns="22860" bIns="13716" anchor="t">
-            <a:spAutoFit/>
-          </a:bodyPr>
-          <a:lstStyle/>
-          <a:p>
-            <a:pPr algn="l">
-              <a:lnSpc>
-                <a:spcPct val="110000"/>
-              </a:lnSpc>
-              <a:spcAft>
-                <a:spcPts val="0"/>
-              </a:spcAft>
-            </a:pPr>
-            <a:r>
-              <a:rPr sz="2400" b="0">
-                <a:solidFill>
-                  <a:srgbClr val="17324D"/>
-                </a:solidFill>
-                <a:latin typeface="DejaVu Sans"/>
-              </a:rPr>
-              <a:t>8</a:t>
-            </a:r>
-          </a:p>
-        </p:txBody>
-      </p:sp>
-      <p:sp>
-        <p:nvSpPr>
-          <p:cNvPr id="29" name="TextBox 28"/>
-          <p:cNvSpPr txBox="1"/>
-          <p:nvPr/>
-        </p:nvSpPr>
-        <p:spPr>
-          <a:xfrm>
-            <a:off x="566928" y="4599432"/>
-            <a:ext cx="256032" cy="448056"/>
-          </a:xfrm>
-          <a:prstGeom prst="rect">
-            <a:avLst/>
-          </a:prstGeom>
-          <a:noFill/>
-        </p:spPr>
-        <p:txBody>
-          <a:bodyPr wrap="square" lIns="22860" rIns="22860" tIns="22860" bIns="13716" anchor="t">
-            <a:spAutoFit/>
-          </a:bodyPr>
-          <a:lstStyle/>
-          <a:p>
-            <a:pPr algn="l">
-              <a:lnSpc>
-                <a:spcPct val="110000"/>
-              </a:lnSpc>
-              <a:spcAft>
-                <a:spcPts val="0"/>
-              </a:spcAft>
-            </a:pPr>
-            <a:r>
-              <a:rPr sz="2400" b="1">
-                <a:solidFill>
-                  <a:srgbClr val="087F7A"/>
-                </a:solidFill>
-                <a:latin typeface="DejaVu Sans"/>
-              </a:rPr>
-              <a:t>•</a:t>
-            </a:r>
-          </a:p>
-        </p:txBody>
-      </p:sp>
-      <p:sp>
-        <p:nvSpPr>
-          <p:cNvPr id="30" name="TextBox 29"/>
-          <p:cNvSpPr txBox="1"/>
-          <p:nvPr/>
-        </p:nvSpPr>
-        <p:spPr>
-          <a:xfrm>
-            <a:off x="914400" y="4599432"/>
-            <a:ext cx="10671048" cy="448056"/>
-          </a:xfrm>
-          <a:prstGeom prst="rect">
-            <a:avLst/>
-          </a:prstGeom>
-          <a:noFill/>
-        </p:spPr>
-        <p:txBody>
-          <a:bodyPr wrap="square" lIns="22860" rIns="22860" tIns="22860" bIns="13716" anchor="t">
-            <a:spAutoFit/>
-          </a:bodyPr>
-          <a:lstStyle/>
-          <a:p>
-            <a:pPr algn="l">
-              <a:lnSpc>
-                <a:spcPct val="110000"/>
-              </a:lnSpc>
-              <a:spcAft>
-                <a:spcPts val="0"/>
-              </a:spcAft>
-            </a:pPr>
-            <a:r>
-              <a:rPr sz="2400" b="0">
-                <a:solidFill>
-                  <a:srgbClr val="17324D"/>
-                </a:solidFill>
-                <a:latin typeface="DejaVu Sans"/>
-              </a:rPr>
-              <a:t>Planilla 2026: 39 inicios y 14 rechazos consignados.</a:t>
-            </a:r>
-          </a:p>
-        </p:txBody>
-      </p:sp>
-      <p:sp>
-        <p:nvSpPr>
-          <p:cNvPr id="31" name="TextBox 30"/>
-          <p:cNvSpPr txBox="1"/>
-          <p:nvPr/>
-        </p:nvSpPr>
-        <p:spPr>
-          <a:xfrm>
-            <a:off x="566928" y="5111496"/>
-            <a:ext cx="256032" cy="448056"/>
-          </a:xfrm>
-          <a:prstGeom prst="rect">
-            <a:avLst/>
-          </a:prstGeom>
-          <a:noFill/>
-        </p:spPr>
-        <p:txBody>
-          <a:bodyPr wrap="square" lIns="22860" rIns="22860" tIns="22860" bIns="13716" anchor="t">
-            <a:spAutoFit/>
-          </a:bodyPr>
-          <a:lstStyle/>
-          <a:p>
-            <a:pPr algn="l">
-              <a:lnSpc>
-                <a:spcPct val="110000"/>
-              </a:lnSpc>
-              <a:spcAft>
-                <a:spcPts val="0"/>
-              </a:spcAft>
-            </a:pPr>
-            <a:r>
-              <a:rPr sz="2400" b="1">
-                <a:solidFill>
-                  <a:srgbClr val="087F7A"/>
-                </a:solidFill>
-                <a:latin typeface="DejaVu Sans"/>
-              </a:rPr>
-              <a:t>•</a:t>
-            </a:r>
-          </a:p>
-        </p:txBody>
-      </p:sp>
-      <p:sp>
-        <p:nvSpPr>
-          <p:cNvPr id="32" name="TextBox 31"/>
-          <p:cNvSpPr txBox="1"/>
-          <p:nvPr/>
-        </p:nvSpPr>
-        <p:spPr>
-          <a:xfrm>
-            <a:off x="914400" y="5111496"/>
-            <a:ext cx="10671048" cy="448056"/>
-          </a:xfrm>
-          <a:prstGeom prst="rect">
-            <a:avLst/>
-          </a:prstGeom>
-          <a:noFill/>
-        </p:spPr>
-        <p:txBody>
-          <a:bodyPr wrap="square" lIns="22860" rIns="22860" tIns="22860" bIns="13716" anchor="t">
-            <a:spAutoFit/>
-          </a:bodyPr>
-          <a:lstStyle/>
-          <a:p>
-            <a:pPr algn="l">
-              <a:lnSpc>
-                <a:spcPct val="110000"/>
-              </a:lnSpc>
-              <a:spcAft>
-                <a:spcPts val="0"/>
-              </a:spcAft>
-            </a:pPr>
-            <a:r>
-              <a:rPr sz="2400" b="0">
-                <a:solidFill>
-                  <a:srgbClr val="17324D"/>
-                </a:solidFill>
-                <a:latin typeface="DejaVu Sans"/>
-              </a:rPr>
-              <a:t>La diferencia de conteos no identifica omisiones caso por caso.</a:t>
-            </a:r>
-          </a:p>
-        </p:txBody>
-      </p:sp>
-      <p:sp>
-        <p:nvSpPr>
-          <p:cNvPr id="33" name="TextBox 32"/>
-          <p:cNvSpPr txBox="1"/>
-          <p:nvPr/>
-        </p:nvSpPr>
-        <p:spPr>
-          <a:xfrm>
-            <a:off x="566928" y="5733288"/>
-            <a:ext cx="11064240" cy="539496"/>
-          </a:xfrm>
-          <a:prstGeom prst="rect">
-            <a:avLst/>
-          </a:prstGeom>
-          <a:noFill/>
-        </p:spPr>
-        <p:txBody>
-          <a:bodyPr wrap="square" lIns="22860" rIns="22860" tIns="22860" bIns="13716" anchor="t">
-            <a:spAutoFit/>
-          </a:bodyPr>
-          <a:lstStyle/>
-          <a:p>
-            <a:pPr algn="l">
-              <a:lnSpc>
-                <a:spcPct val="110000"/>
-              </a:lnSpc>
-              <a:spcAft>
-                <a:spcPts val="400"/>
-              </a:spcAft>
-            </a:pPr>
-            <a:r>
-              <a:rPr sz="1400" b="0">
-                <a:solidFill>
-                  <a:srgbClr val="586B7C"/>
-                </a:solidFill>
-                <a:latin typeface="DejaVu Sans"/>
-              </a:rPr>
-              <a:t>Gráfico / tabla: diferencia de 3 casos en 2025 y 8 en 2026; coincide con recaídas, hipótesis sin confirmar.</a:t>
-            </a:r>
-          </a:p>
-          <a:p>
-            <a:pPr algn="l">
-              <a:lnSpc>
-                <a:spcPct val="110000"/>
-              </a:lnSpc>
-              <a:spcAft>
-                <a:spcPts val="400"/>
-              </a:spcAft>
-            </a:pPr>
-            <a:r>
-              <a:rPr sz="1400" b="0">
-                <a:solidFill>
-                  <a:srgbClr val="586B7C"/>
-                </a:solidFill>
-                <a:latin typeface="DejaVu Sans"/>
-              </a:rPr>
-              <a:t>Las frecuencias del portal usan 12 meses.</a:t>
             </a:r>
           </a:p>
         </p:txBody>

</xml_diff>

<commit_message>
Add DEA controls and oxygen equipment to the presentation
</commit_message>
<xml_diff>
--- a/Presentacion_Gestion_Integral_2026.pptx
+++ b/Presentacion_Gestion_Integral_2026.pptx
@@ -15,6 +15,7 @@
     <p:sldId id="263" r:id="rId15"/>
     <p:sldId id="264" r:id="rId16"/>
     <p:sldId id="265" r:id="rId17"/>
+    <p:sldId id="266" r:id="rId18"/>
   </p:sldIdLst>
   <p:sldSz cx="12191999" cy="6858000" type="screen4x3"/>
   <p:notesSz cx="6858000" cy="9144000"/>
@@ -581,6 +582,76 @@
           <a:lstStyle/>
           <a:p>
             <a:r>
+              <a:t>Semestre2026:18895h médicas/400632h teóricas=4.7163%;2025:15729/401112=3.92135%. Cambio exacto0.79495pp, se muestra+0.795pp. BP está incluido en enfermedad; no se añade. Ratios de sumas, no promedio de porcentajes mensuales. La serie contextualiza carga y no establece causalidad del Servicio Médico.</a:t>
+            </a:r>
+          </a:p>
+        </p:txBody>
+      </p:sp>
+      <p:sp>
+        <p:nvSpPr>
+          <p:cNvPr id="4" name="Slide Number Placeholder 3"/>
+          <p:cNvSpPr>
+            <a:spLocks noGrp="1"/>
+          </p:cNvSpPr>
+          <p:nvPr>
+            <p:ph type="sldNum" idx="5" sz="quarter"/>
+          </p:nvPr>
+        </p:nvSpPr>
+        <p:spPr/>
+      </p:sp>
+    </p:spTree>
+  </p:cSld>
+  <p:clrMapOvr>
+    <a:masterClrMapping/>
+  </p:clrMapOvr>
+</p:notes>
+</file>
+
+<file path=ppt/notesSlides/notesSlide11.xml><?xml version="1.0" encoding="utf-8"?>
+<p:notes xmlns:a="http://schemas.openxmlformats.org/drawingml/2006/main" xmlns:p="http://schemas.openxmlformats.org/presentationml/2006/main" xmlns:r="http://schemas.openxmlformats.org/officeDocument/2006/relationships">
+  <p:cSld>
+    <p:spTree>
+      <p:nvGrpSpPr>
+        <p:cNvPr id="1" name=""/>
+        <p:cNvGrpSpPr/>
+        <p:nvPr/>
+      </p:nvGrpSpPr>
+      <p:grpSpPr>
+        <a:xfrm>
+          <a:off x="0" y="0"/>
+          <a:ext cx="0" cy="0"/>
+          <a:chOff x="0" y="0"/>
+          <a:chExt cx="0" cy="0"/>
+        </a:xfrm>
+      </p:grpSpPr>
+      <p:sp>
+        <p:nvSpPr>
+          <p:cNvPr id="2" name="Slide Image Placeholder 1"/>
+          <p:cNvSpPr>
+            <a:spLocks noGrp="1"/>
+          </p:cNvSpPr>
+          <p:nvPr>
+            <p:ph type="sldImg" idx="2"/>
+          </p:nvPr>
+        </p:nvSpPr>
+        <p:spPr/>
+      </p:sp>
+      <p:sp>
+        <p:nvSpPr>
+          <p:cNvPr id="3" name="Notes Placeholder 2"/>
+          <p:cNvSpPr>
+            <a:spLocks noGrp="1"/>
+          </p:cNvSpPr>
+          <p:nvPr>
+            <p:ph type="body" idx="3" sz="quarter"/>
+          </p:nvPr>
+        </p:nvSpPr>
+        <p:spPr/>
+        <p:txBody>
+          <a:bodyPr/>
+          <a:lstStyle/>
+          <a:p>
+            <a:r>
               <a:t>Los informes originales de ProvinciaART informan82denuncias2025 y56en2026,16y25rechazos; gráficos norechazados66y31. Reducción denuncias31.7%, aumento rechazos56.25%, participación16/82=19.5% a25/56=44.6%. No se atribuye causalidad a gestión médica. Las frecuencias siniestral y judicial son12meses y no se usan como tasas9meses.</a:t>
             </a:r>
           </a:p>
@@ -1141,7 +1212,7 @@
           <a:lstStyle/>
           <a:p>
             <a:r>
-              <a:t>Semestre2026:18895h médicas/400632h teóricas=4.7163%;2025:15729/401112=3.92135%. Cambio exacto0.79495pp, se muestra+0.795pp. BP está incluido en enfermedad; no se añade. Ratios de sumas, no promedio de porcentajes mensuales. La serie contextualiza carga y no establece causalidad del Servicio Médico.</a:t>
+              <a:t>Fuente: Copia de Control_Completo_Servicio_Medico_Astillero2.xlsx. Dea!A2:A5 contiene4DEA; K2:K5 fechas de último control11/03,01/05,01/03y01/05de2026: los cuatro dentrode1S. I2:I5 muestra3operativosy1fuera de servicio. Oxigeno!A2:A8 contiene7cilindros;H2:H8 muestra6operativosy1nooperativo. El inventario no tiene fecha de corte confirmada; no se afirma disponibilidad histórica durante todo el semestre. Oxigeno no incluye fecha de control. Los vencimientos de F no se interpretan como controles. Distribución de oxígeno:3ShockRoom,1unidad de traslado,3ambulancia. No se expone información personal ni se afirma que el DEA retirado para reposición ya fue repuesto.</a:t>
             </a:r>
           </a:p>
         </p:txBody>
@@ -5325,7 +5396,7 @@
                 </a:solidFill>
                 <a:latin typeface="DejaVu Sans"/>
               </a:rPr>
-              <a:t>Siniestralidad ART: comparación de nueve meses</a:t>
+              <a:t>Ausentismo médico: dimensión del impacto laboral</a:t>
             </a:r>
           </a:p>
         </p:txBody>
@@ -5367,7 +5438,7 @@
                 </a:solidFill>
                 <a:latin typeface="DejaVu Sans"/>
               </a:rPr>
-              <a:t>Enero–septiembre 2025 frente a enero–septiembre 2026 · Fuente: informes originales de Provincia ART</a:t>
+              <a:t>Enero–junio · Enfermedad + ART / horas teóricas</a:t>
             </a:r>
           </a:p>
         </p:txBody>
@@ -5452,7 +5523,7 @@
                 </a:solidFill>
                 <a:latin typeface="DejaVu Sans"/>
               </a:rPr>
-              <a:t>Siniestralidad · Enero–septiembre  ·  8 de octubre de 2026  ·  Provincia ART · PDF originales / pág. 1</a:t>
+              <a:t>Enero–junio 2026  ·  8 de octubre de 2026  ·  Indicadores de ausentismo RRHH · Enero–junio</a:t>
             </a:r>
           </a:p>
         </p:txBody>
@@ -5495,6 +5566,910 @@
                 <a:latin typeface="DejaVu Sans"/>
               </a:rPr>
               <a:t>10</a:t>
+            </a:r>
+          </a:p>
+        </p:txBody>
+      </p:sp>
+      <p:sp>
+        <p:nvSpPr>
+          <p:cNvPr id="9" name="Rounded Rectangle 8"/>
+          <p:cNvSpPr/>
+          <p:nvPr/>
+        </p:nvSpPr>
+        <p:spPr>
+          <a:xfrm>
+            <a:off x="566928" y="1883664"/>
+            <a:ext cx="2743200" cy="1719072"/>
+          </a:xfrm>
+          <a:prstGeom prst="roundRect">
+            <a:avLst>
+              <a:gd name="adj" fmla="val 8000"/>
+            </a:avLst>
+          </a:prstGeom>
+          <a:solidFill>
+            <a:srgbClr val="EDF5F6"/>
+          </a:solidFill>
+          <a:ln>
+            <a:noFill/>
+          </a:ln>
+        </p:spPr>
+        <p:style>
+          <a:lnRef idx="1">
+            <a:schemeClr val="accent1"/>
+          </a:lnRef>
+          <a:fillRef idx="3">
+            <a:schemeClr val="accent1"/>
+          </a:fillRef>
+          <a:effectRef idx="2">
+            <a:schemeClr val="accent1"/>
+          </a:effectRef>
+          <a:fontRef idx="minor">
+            <a:schemeClr val="lt1"/>
+          </a:fontRef>
+        </p:style>
+        <p:txBody>
+          <a:bodyPr rtlCol="0" anchor="ctr"/>
+          <a:lstStyle/>
+          <a:p>
+            <a:pPr algn="ctr"/>
+          </a:p>
+        </p:txBody>
+      </p:sp>
+      <p:sp>
+        <p:nvSpPr>
+          <p:cNvPr id="10" name="Rectangle 9"/>
+          <p:cNvSpPr/>
+          <p:nvPr/>
+        </p:nvSpPr>
+        <p:spPr>
+          <a:xfrm>
+            <a:off x="566928" y="1883664"/>
+            <a:ext cx="50292" cy="1719072"/>
+          </a:xfrm>
+          <a:prstGeom prst="rect">
+            <a:avLst/>
+          </a:prstGeom>
+          <a:solidFill>
+            <a:srgbClr val="087F7A"/>
+          </a:solidFill>
+          <a:ln>
+            <a:noFill/>
+          </a:ln>
+        </p:spPr>
+        <p:style>
+          <a:lnRef idx="1">
+            <a:schemeClr val="accent1"/>
+          </a:lnRef>
+          <a:fillRef idx="3">
+            <a:schemeClr val="accent1"/>
+          </a:fillRef>
+          <a:effectRef idx="2">
+            <a:schemeClr val="accent1"/>
+          </a:effectRef>
+          <a:fontRef idx="minor">
+            <a:schemeClr val="lt1"/>
+          </a:fontRef>
+        </p:style>
+        <p:txBody>
+          <a:bodyPr rtlCol="0" anchor="ctr"/>
+          <a:lstStyle/>
+          <a:p>
+            <a:pPr algn="ctr"/>
+          </a:p>
+        </p:txBody>
+      </p:sp>
+      <p:sp>
+        <p:nvSpPr>
+          <p:cNvPr id="11" name="TextBox 10"/>
+          <p:cNvSpPr txBox="1"/>
+          <p:nvPr/>
+        </p:nvSpPr>
+        <p:spPr>
+          <a:xfrm>
+            <a:off x="722376" y="2002536"/>
+            <a:ext cx="2432304" cy="557784"/>
+          </a:xfrm>
+          <a:prstGeom prst="rect">
+            <a:avLst/>
+          </a:prstGeom>
+          <a:noFill/>
+        </p:spPr>
+        <p:txBody>
+          <a:bodyPr wrap="square" lIns="22860" rIns="22860" tIns="22860" bIns="13716" anchor="t">
+            <a:spAutoFit/>
+          </a:bodyPr>
+          <a:lstStyle/>
+          <a:p>
+            <a:pPr algn="l">
+              <a:lnSpc>
+                <a:spcPct val="110000"/>
+              </a:lnSpc>
+              <a:spcAft>
+                <a:spcPts val="0"/>
+              </a:spcAft>
+            </a:pPr>
+            <a:r>
+              <a:rPr sz="3500" b="1">
+                <a:solidFill>
+                  <a:srgbClr val="087F7A"/>
+                </a:solidFill>
+                <a:latin typeface="DejaVu Sans"/>
+              </a:rPr>
+              <a:t>4,72%</a:t>
+            </a:r>
+          </a:p>
+        </p:txBody>
+      </p:sp>
+      <p:sp>
+        <p:nvSpPr>
+          <p:cNvPr id="12" name="TextBox 11"/>
+          <p:cNvSpPr txBox="1"/>
+          <p:nvPr/>
+        </p:nvSpPr>
+        <p:spPr>
+          <a:xfrm>
+            <a:off x="722376" y="2660904"/>
+            <a:ext cx="2432304" cy="640080"/>
+          </a:xfrm>
+          <a:prstGeom prst="rect">
+            <a:avLst/>
+          </a:prstGeom>
+          <a:noFill/>
+        </p:spPr>
+        <p:txBody>
+          <a:bodyPr wrap="square" lIns="22860" rIns="22860" tIns="22860" bIns="13716" anchor="t">
+            <a:spAutoFit/>
+          </a:bodyPr>
+          <a:lstStyle/>
+          <a:p>
+            <a:pPr algn="l">
+              <a:lnSpc>
+                <a:spcPct val="110000"/>
+              </a:lnSpc>
+              <a:spcAft>
+                <a:spcPts val="0"/>
+              </a:spcAft>
+            </a:pPr>
+            <a:r>
+              <a:rPr sz="1800" b="1">
+                <a:solidFill>
+                  <a:srgbClr val="17324D"/>
+                </a:solidFill>
+                <a:latin typeface="DejaVu Sans"/>
+              </a:rPr>
+              <a:t>Semestre 2026</a:t>
+            </a:r>
+          </a:p>
+        </p:txBody>
+      </p:sp>
+      <p:sp>
+        <p:nvSpPr>
+          <p:cNvPr id="13" name="TextBox 12"/>
+          <p:cNvSpPr txBox="1"/>
+          <p:nvPr/>
+        </p:nvSpPr>
+        <p:spPr>
+          <a:xfrm>
+            <a:off x="722376" y="3118104"/>
+            <a:ext cx="2432304" cy="411480"/>
+          </a:xfrm>
+          <a:prstGeom prst="rect">
+            <a:avLst/>
+          </a:prstGeom>
+          <a:noFill/>
+        </p:spPr>
+        <p:txBody>
+          <a:bodyPr wrap="square" lIns="22860" rIns="22860" tIns="22860" bIns="13716" anchor="t">
+            <a:spAutoFit/>
+          </a:bodyPr>
+          <a:lstStyle/>
+          <a:p>
+            <a:pPr algn="l">
+              <a:lnSpc>
+                <a:spcPct val="110000"/>
+              </a:lnSpc>
+              <a:spcAft>
+                <a:spcPts val="0"/>
+              </a:spcAft>
+            </a:pPr>
+            <a:r>
+              <a:rPr sz="1400" b="0">
+                <a:solidFill>
+                  <a:srgbClr val="586B7C"/>
+                </a:solidFill>
+                <a:latin typeface="DejaVu Sans"/>
+              </a:rPr>
+              <a:t>18.895 horas médicas</a:t>
+            </a:r>
+          </a:p>
+        </p:txBody>
+      </p:sp>
+      <p:sp>
+        <p:nvSpPr>
+          <p:cNvPr id="14" name="Rounded Rectangle 13"/>
+          <p:cNvSpPr/>
+          <p:nvPr/>
+        </p:nvSpPr>
+        <p:spPr>
+          <a:xfrm>
+            <a:off x="566928" y="3822191"/>
+            <a:ext cx="2743200" cy="1719072"/>
+          </a:xfrm>
+          <a:prstGeom prst="roundRect">
+            <a:avLst>
+              <a:gd name="adj" fmla="val 8000"/>
+            </a:avLst>
+          </a:prstGeom>
+          <a:solidFill>
+            <a:srgbClr val="EDF5F6"/>
+          </a:solidFill>
+          <a:ln>
+            <a:noFill/>
+          </a:ln>
+        </p:spPr>
+        <p:style>
+          <a:lnRef idx="1">
+            <a:schemeClr val="accent1"/>
+          </a:lnRef>
+          <a:fillRef idx="3">
+            <a:schemeClr val="accent1"/>
+          </a:fillRef>
+          <a:effectRef idx="2">
+            <a:schemeClr val="accent1"/>
+          </a:effectRef>
+          <a:fontRef idx="minor">
+            <a:schemeClr val="lt1"/>
+          </a:fontRef>
+        </p:style>
+        <p:txBody>
+          <a:bodyPr rtlCol="0" anchor="ctr"/>
+          <a:lstStyle/>
+          <a:p>
+            <a:pPr algn="ctr"/>
+          </a:p>
+        </p:txBody>
+      </p:sp>
+      <p:sp>
+        <p:nvSpPr>
+          <p:cNvPr id="15" name="Rectangle 14"/>
+          <p:cNvSpPr/>
+          <p:nvPr/>
+        </p:nvSpPr>
+        <p:spPr>
+          <a:xfrm>
+            <a:off x="566928" y="3822191"/>
+            <a:ext cx="50292" cy="1719072"/>
+          </a:xfrm>
+          <a:prstGeom prst="rect">
+            <a:avLst/>
+          </a:prstGeom>
+          <a:solidFill>
+            <a:srgbClr val="6386A8"/>
+          </a:solidFill>
+          <a:ln>
+            <a:noFill/>
+          </a:ln>
+        </p:spPr>
+        <p:style>
+          <a:lnRef idx="1">
+            <a:schemeClr val="accent1"/>
+          </a:lnRef>
+          <a:fillRef idx="3">
+            <a:schemeClr val="accent1"/>
+          </a:fillRef>
+          <a:effectRef idx="2">
+            <a:schemeClr val="accent1"/>
+          </a:effectRef>
+          <a:fontRef idx="minor">
+            <a:schemeClr val="lt1"/>
+          </a:fontRef>
+        </p:style>
+        <p:txBody>
+          <a:bodyPr rtlCol="0" anchor="ctr"/>
+          <a:lstStyle/>
+          <a:p>
+            <a:pPr algn="ctr"/>
+          </a:p>
+        </p:txBody>
+      </p:sp>
+      <p:sp>
+        <p:nvSpPr>
+          <p:cNvPr id="16" name="TextBox 15"/>
+          <p:cNvSpPr txBox="1"/>
+          <p:nvPr/>
+        </p:nvSpPr>
+        <p:spPr>
+          <a:xfrm>
+            <a:off x="722376" y="3941063"/>
+            <a:ext cx="2432304" cy="557784"/>
+          </a:xfrm>
+          <a:prstGeom prst="rect">
+            <a:avLst/>
+          </a:prstGeom>
+          <a:noFill/>
+        </p:spPr>
+        <p:txBody>
+          <a:bodyPr wrap="square" lIns="22860" rIns="22860" tIns="22860" bIns="13716" anchor="t">
+            <a:spAutoFit/>
+          </a:bodyPr>
+          <a:lstStyle/>
+          <a:p>
+            <a:pPr algn="l">
+              <a:lnSpc>
+                <a:spcPct val="110000"/>
+              </a:lnSpc>
+              <a:spcAft>
+                <a:spcPts val="0"/>
+              </a:spcAft>
+            </a:pPr>
+            <a:r>
+              <a:rPr sz="3500" b="1">
+                <a:solidFill>
+                  <a:srgbClr val="6386A8"/>
+                </a:solidFill>
+                <a:latin typeface="DejaVu Sans"/>
+              </a:rPr>
+              <a:t>3,92%</a:t>
+            </a:r>
+          </a:p>
+        </p:txBody>
+      </p:sp>
+      <p:sp>
+        <p:nvSpPr>
+          <p:cNvPr id="17" name="TextBox 16"/>
+          <p:cNvSpPr txBox="1"/>
+          <p:nvPr/>
+        </p:nvSpPr>
+        <p:spPr>
+          <a:xfrm>
+            <a:off x="722376" y="4599431"/>
+            <a:ext cx="2432304" cy="640080"/>
+          </a:xfrm>
+          <a:prstGeom prst="rect">
+            <a:avLst/>
+          </a:prstGeom>
+          <a:noFill/>
+        </p:spPr>
+        <p:txBody>
+          <a:bodyPr wrap="square" lIns="22860" rIns="22860" tIns="22860" bIns="13716" anchor="t">
+            <a:spAutoFit/>
+          </a:bodyPr>
+          <a:lstStyle/>
+          <a:p>
+            <a:pPr algn="l">
+              <a:lnSpc>
+                <a:spcPct val="110000"/>
+              </a:lnSpc>
+              <a:spcAft>
+                <a:spcPts val="0"/>
+              </a:spcAft>
+            </a:pPr>
+            <a:r>
+              <a:rPr sz="1800" b="1">
+                <a:solidFill>
+                  <a:srgbClr val="17324D"/>
+                </a:solidFill>
+                <a:latin typeface="DejaVu Sans"/>
+              </a:rPr>
+              <a:t>Semestre 2025</a:t>
+            </a:r>
+          </a:p>
+        </p:txBody>
+      </p:sp>
+      <p:sp>
+        <p:nvSpPr>
+          <p:cNvPr id="18" name="TextBox 17"/>
+          <p:cNvSpPr txBox="1"/>
+          <p:nvPr/>
+        </p:nvSpPr>
+        <p:spPr>
+          <a:xfrm>
+            <a:off x="722376" y="5056631"/>
+            <a:ext cx="2432304" cy="411480"/>
+          </a:xfrm>
+          <a:prstGeom prst="rect">
+            <a:avLst/>
+          </a:prstGeom>
+          <a:noFill/>
+        </p:spPr>
+        <p:txBody>
+          <a:bodyPr wrap="square" lIns="22860" rIns="22860" tIns="22860" bIns="13716" anchor="t">
+            <a:spAutoFit/>
+          </a:bodyPr>
+          <a:lstStyle/>
+          <a:p>
+            <a:pPr algn="l">
+              <a:lnSpc>
+                <a:spcPct val="110000"/>
+              </a:lnSpc>
+              <a:spcAft>
+                <a:spcPts val="0"/>
+              </a:spcAft>
+            </a:pPr>
+            <a:r>
+              <a:rPr sz="1400" b="0">
+                <a:solidFill>
+                  <a:srgbClr val="586B7C"/>
+                </a:solidFill>
+                <a:latin typeface="DejaVu Sans"/>
+              </a:rPr>
+              <a:t>15.729 horas médicas</a:t>
+            </a:r>
+          </a:p>
+        </p:txBody>
+      </p:sp>
+      <p:pic>
+        <p:nvPicPr>
+          <p:cNvPr id="19" name="Picture 18" descr="ausentismo.png"/>
+          <p:cNvPicPr>
+            <a:picLocks noChangeAspect="1"/>
+          </p:cNvPicPr>
+          <p:nvPr/>
+        </p:nvPicPr>
+        <p:blipFill>
+          <a:blip r:embed="rId3"/>
+          <a:stretch>
+            <a:fillRect/>
+          </a:stretch>
+        </p:blipFill>
+        <p:spPr>
+          <a:xfrm>
+            <a:off x="3685032" y="2139847"/>
+            <a:ext cx="7909560" cy="3117801"/>
+          </a:xfrm>
+          <a:prstGeom prst="rect">
+            <a:avLst/>
+          </a:prstGeom>
+        </p:spPr>
+      </p:pic>
+      <p:sp>
+        <p:nvSpPr>
+          <p:cNvPr id="20" name="Rounded Rectangle 19"/>
+          <p:cNvSpPr/>
+          <p:nvPr/>
+        </p:nvSpPr>
+        <p:spPr>
+          <a:xfrm>
+            <a:off x="566928" y="5623560"/>
+            <a:ext cx="11064240" cy="630936"/>
+          </a:xfrm>
+          <a:prstGeom prst="roundRect">
+            <a:avLst>
+              <a:gd name="adj" fmla="val 8000"/>
+            </a:avLst>
+          </a:prstGeom>
+          <a:solidFill>
+            <a:srgbClr val="EDF5F6"/>
+          </a:solidFill>
+          <a:ln>
+            <a:noFill/>
+          </a:ln>
+        </p:spPr>
+        <p:style>
+          <a:lnRef idx="1">
+            <a:schemeClr val="accent1"/>
+          </a:lnRef>
+          <a:fillRef idx="3">
+            <a:schemeClr val="accent1"/>
+          </a:fillRef>
+          <a:effectRef idx="2">
+            <a:schemeClr val="accent1"/>
+          </a:effectRef>
+          <a:fontRef idx="minor">
+            <a:schemeClr val="lt1"/>
+          </a:fontRef>
+        </p:style>
+        <p:txBody>
+          <a:bodyPr rtlCol="0" anchor="ctr"/>
+          <a:lstStyle/>
+          <a:p>
+            <a:pPr algn="ctr"/>
+          </a:p>
+        </p:txBody>
+      </p:sp>
+      <p:sp>
+        <p:nvSpPr>
+          <p:cNvPr id="21" name="Rectangle 20"/>
+          <p:cNvSpPr/>
+          <p:nvPr/>
+        </p:nvSpPr>
+        <p:spPr>
+          <a:xfrm>
+            <a:off x="566928" y="5623560"/>
+            <a:ext cx="54864" cy="630936"/>
+          </a:xfrm>
+          <a:prstGeom prst="rect">
+            <a:avLst/>
+          </a:prstGeom>
+          <a:solidFill>
+            <a:srgbClr val="087F7A"/>
+          </a:solidFill>
+          <a:ln>
+            <a:noFill/>
+          </a:ln>
+        </p:spPr>
+        <p:style>
+          <a:lnRef idx="1">
+            <a:schemeClr val="accent1"/>
+          </a:lnRef>
+          <a:fillRef idx="3">
+            <a:schemeClr val="accent1"/>
+          </a:fillRef>
+          <a:effectRef idx="2">
+            <a:schemeClr val="accent1"/>
+          </a:effectRef>
+          <a:fontRef idx="minor">
+            <a:schemeClr val="lt1"/>
+          </a:fontRef>
+        </p:style>
+        <p:txBody>
+          <a:bodyPr rtlCol="0" anchor="ctr"/>
+          <a:lstStyle/>
+          <a:p>
+            <a:pPr algn="ctr"/>
+          </a:p>
+        </p:txBody>
+      </p:sp>
+      <p:sp>
+        <p:nvSpPr>
+          <p:cNvPr id="22" name="TextBox 21"/>
+          <p:cNvSpPr txBox="1"/>
+          <p:nvPr/>
+        </p:nvSpPr>
+        <p:spPr>
+          <a:xfrm>
+            <a:off x="713232" y="5696712"/>
+            <a:ext cx="10725912" cy="512063"/>
+          </a:xfrm>
+          <a:prstGeom prst="rect">
+            <a:avLst/>
+          </a:prstGeom>
+          <a:noFill/>
+        </p:spPr>
+        <p:txBody>
+          <a:bodyPr wrap="square" lIns="22860" rIns="22860" tIns="22860" bIns="13716" anchor="t">
+            <a:spAutoFit/>
+          </a:bodyPr>
+          <a:lstStyle/>
+          <a:p>
+            <a:pPr algn="l">
+              <a:lnSpc>
+                <a:spcPct val="110000"/>
+              </a:lnSpc>
+              <a:spcAft>
+                <a:spcPts val="0"/>
+              </a:spcAft>
+            </a:pPr>
+            <a:r>
+              <a:rPr sz="1850" b="0">
+                <a:solidFill>
+                  <a:srgbClr val="17324D"/>
+                </a:solidFill>
+                <a:latin typeface="DejaVu Sans"/>
+              </a:rPr>
+              <a:t>Cambio interanual: +0,795 puntos porcentuales. BP se incluye en enfermedad.</a:t>
+            </a:r>
+          </a:p>
+        </p:txBody>
+      </p:sp>
+    </p:spTree>
+  </p:cSld>
+  <p:clrMapOvr>
+    <a:masterClrMapping/>
+  </p:clrMapOvr>
+</p:sld>
+</file>
+
+<file path=ppt/slides/slide11.xml><?xml version="1.0" encoding="utf-8"?>
+<p:sld xmlns:a="http://schemas.openxmlformats.org/drawingml/2006/main" xmlns:p="http://schemas.openxmlformats.org/presentationml/2006/main" xmlns:r="http://schemas.openxmlformats.org/officeDocument/2006/relationships">
+  <p:cSld>
+    <p:bg>
+      <p:bgPr>
+        <a:solidFill>
+          <a:srgbClr val="FFFFFF"/>
+        </a:solidFill>
+        <a:effectLst/>
+      </p:bgPr>
+    </p:bg>
+    <p:spTree>
+      <p:nvGrpSpPr>
+        <p:cNvPr id="1" name=""/>
+        <p:cNvGrpSpPr/>
+        <p:nvPr/>
+      </p:nvGrpSpPr>
+      <p:grpSpPr/>
+      <p:sp>
+        <p:nvSpPr>
+          <p:cNvPr id="2" name="Rectangle 1"/>
+          <p:cNvSpPr/>
+          <p:nvPr/>
+        </p:nvSpPr>
+        <p:spPr>
+          <a:xfrm>
+            <a:off x="0" y="0"/>
+            <a:ext cx="12191999" cy="109728"/>
+          </a:xfrm>
+          <a:prstGeom prst="rect">
+            <a:avLst/>
+          </a:prstGeom>
+          <a:solidFill>
+            <a:srgbClr val="087F7A"/>
+          </a:solidFill>
+          <a:ln>
+            <a:noFill/>
+          </a:ln>
+        </p:spPr>
+        <p:style>
+          <a:lnRef idx="1">
+            <a:schemeClr val="accent1"/>
+          </a:lnRef>
+          <a:fillRef idx="3">
+            <a:schemeClr val="accent1"/>
+          </a:fillRef>
+          <a:effectRef idx="2">
+            <a:schemeClr val="accent1"/>
+          </a:effectRef>
+          <a:fontRef idx="minor">
+            <a:schemeClr val="lt1"/>
+          </a:fontRef>
+        </p:style>
+        <p:txBody>
+          <a:bodyPr rtlCol="0" anchor="ctr"/>
+          <a:lstStyle/>
+          <a:p>
+            <a:pPr algn="ctr"/>
+          </a:p>
+        </p:txBody>
+      </p:sp>
+      <p:sp>
+        <p:nvSpPr>
+          <p:cNvPr id="3" name="TextBox 2"/>
+          <p:cNvSpPr txBox="1"/>
+          <p:nvPr/>
+        </p:nvSpPr>
+        <p:spPr>
+          <a:xfrm>
+            <a:off x="566928" y="219456"/>
+            <a:ext cx="11064240" cy="292608"/>
+          </a:xfrm>
+          <a:prstGeom prst="rect">
+            <a:avLst/>
+          </a:prstGeom>
+          <a:noFill/>
+        </p:spPr>
+        <p:txBody>
+          <a:bodyPr wrap="square" lIns="22860" rIns="22860" tIns="22860" bIns="13716" anchor="t">
+            <a:spAutoFit/>
+          </a:bodyPr>
+          <a:lstStyle/>
+          <a:p>
+            <a:pPr algn="l">
+              <a:lnSpc>
+                <a:spcPct val="110000"/>
+              </a:lnSpc>
+              <a:spcAft>
+                <a:spcPts val="0"/>
+              </a:spcAft>
+            </a:pPr>
+            <a:r>
+              <a:rPr sz="1400" b="1">
+                <a:solidFill>
+                  <a:srgbClr val="087F7A"/>
+                </a:solidFill>
+                <a:latin typeface="DejaVu Sans"/>
+              </a:rPr>
+              <a:t>SERVICIO MÉDICO  /  TANDANOR</a:t>
+            </a:r>
+          </a:p>
+        </p:txBody>
+      </p:sp>
+      <p:sp>
+        <p:nvSpPr>
+          <p:cNvPr id="4" name="TextBox 3"/>
+          <p:cNvSpPr txBox="1"/>
+          <p:nvPr/>
+        </p:nvSpPr>
+        <p:spPr>
+          <a:xfrm>
+            <a:off x="566928" y="694944"/>
+            <a:ext cx="11064240" cy="502920"/>
+          </a:xfrm>
+          <a:prstGeom prst="rect">
+            <a:avLst/>
+          </a:prstGeom>
+          <a:noFill/>
+        </p:spPr>
+        <p:txBody>
+          <a:bodyPr wrap="square" lIns="22860" rIns="22860" tIns="22860" bIns="13716" anchor="t">
+            <a:spAutoFit/>
+          </a:bodyPr>
+          <a:lstStyle/>
+          <a:p>
+            <a:pPr algn="l">
+              <a:lnSpc>
+                <a:spcPct val="110000"/>
+              </a:lnSpc>
+              <a:spcAft>
+                <a:spcPts val="0"/>
+              </a:spcAft>
+            </a:pPr>
+            <a:r>
+              <a:rPr sz="2900" b="1">
+                <a:solidFill>
+                  <a:srgbClr val="17324D"/>
+                </a:solidFill>
+                <a:latin typeface="DejaVu Sans"/>
+              </a:rPr>
+              <a:t>Siniestralidad ART: comparación de nueve meses</a:t>
+            </a:r>
+          </a:p>
+        </p:txBody>
+      </p:sp>
+      <p:sp>
+        <p:nvSpPr>
+          <p:cNvPr id="5" name="TextBox 4"/>
+          <p:cNvSpPr txBox="1"/>
+          <p:nvPr/>
+        </p:nvSpPr>
+        <p:spPr>
+          <a:xfrm>
+            <a:off x="566928" y="1271016"/>
+            <a:ext cx="11064240" cy="384048"/>
+          </a:xfrm>
+          <a:prstGeom prst="rect">
+            <a:avLst/>
+          </a:prstGeom>
+          <a:noFill/>
+        </p:spPr>
+        <p:txBody>
+          <a:bodyPr wrap="square" lIns="22860" rIns="22860" tIns="22860" bIns="13716" anchor="t">
+            <a:spAutoFit/>
+          </a:bodyPr>
+          <a:lstStyle/>
+          <a:p>
+            <a:pPr algn="l">
+              <a:lnSpc>
+                <a:spcPct val="110000"/>
+              </a:lnSpc>
+              <a:spcAft>
+                <a:spcPts val="0"/>
+              </a:spcAft>
+            </a:pPr>
+            <a:r>
+              <a:rPr sz="1600" b="0">
+                <a:solidFill>
+                  <a:srgbClr val="586B7C"/>
+                </a:solidFill>
+                <a:latin typeface="DejaVu Sans"/>
+              </a:rPr>
+              <a:t>Enero–septiembre 2025 frente a enero–septiembre 2026 · Fuente: informes originales de Provincia ART</a:t>
+            </a:r>
+          </a:p>
+        </p:txBody>
+      </p:sp>
+      <p:sp>
+        <p:nvSpPr>
+          <p:cNvPr id="6" name="Rectangle 5"/>
+          <p:cNvSpPr/>
+          <p:nvPr/>
+        </p:nvSpPr>
+        <p:spPr>
+          <a:xfrm>
+            <a:off x="566928" y="6364224"/>
+            <a:ext cx="11064240" cy="11887"/>
+          </a:xfrm>
+          <a:prstGeom prst="rect">
+            <a:avLst/>
+          </a:prstGeom>
+          <a:solidFill>
+            <a:srgbClr val="D6E2E8"/>
+          </a:solidFill>
+          <a:ln>
+            <a:noFill/>
+          </a:ln>
+        </p:spPr>
+        <p:style>
+          <a:lnRef idx="1">
+            <a:schemeClr val="accent1"/>
+          </a:lnRef>
+          <a:fillRef idx="3">
+            <a:schemeClr val="accent1"/>
+          </a:fillRef>
+          <a:effectRef idx="2">
+            <a:schemeClr val="accent1"/>
+          </a:effectRef>
+          <a:fontRef idx="minor">
+            <a:schemeClr val="lt1"/>
+          </a:fontRef>
+        </p:style>
+        <p:txBody>
+          <a:bodyPr rtlCol="0" anchor="ctr"/>
+          <a:lstStyle/>
+          <a:p>
+            <a:pPr algn="ctr"/>
+          </a:p>
+        </p:txBody>
+      </p:sp>
+      <p:sp>
+        <p:nvSpPr>
+          <p:cNvPr id="7" name="TextBox 6"/>
+          <p:cNvSpPr txBox="1"/>
+          <p:nvPr/>
+        </p:nvSpPr>
+        <p:spPr>
+          <a:xfrm>
+            <a:off x="566928" y="6473952"/>
+            <a:ext cx="9875520" cy="201168"/>
+          </a:xfrm>
+          <a:prstGeom prst="rect">
+            <a:avLst/>
+          </a:prstGeom>
+          <a:noFill/>
+        </p:spPr>
+        <p:txBody>
+          <a:bodyPr wrap="square" lIns="22860" rIns="22860" tIns="22860" bIns="13716" anchor="t">
+            <a:spAutoFit/>
+          </a:bodyPr>
+          <a:lstStyle/>
+          <a:p>
+            <a:pPr algn="l">
+              <a:lnSpc>
+                <a:spcPct val="110000"/>
+              </a:lnSpc>
+              <a:spcAft>
+                <a:spcPts val="0"/>
+              </a:spcAft>
+            </a:pPr>
+            <a:r>
+              <a:rPr sz="1150" b="0">
+                <a:solidFill>
+                  <a:srgbClr val="586B7C"/>
+                </a:solidFill>
+                <a:latin typeface="DejaVu Sans"/>
+              </a:rPr>
+              <a:t>Siniestralidad · Enero–septiembre  ·  8 de octubre de 2026  ·  Provincia ART · PDF originales / pág. 1</a:t>
+            </a:r>
+          </a:p>
+        </p:txBody>
+      </p:sp>
+      <p:sp>
+        <p:nvSpPr>
+          <p:cNvPr id="8" name="TextBox 7"/>
+          <p:cNvSpPr txBox="1"/>
+          <p:nvPr/>
+        </p:nvSpPr>
+        <p:spPr>
+          <a:xfrm>
+            <a:off x="11045952" y="6455664"/>
+            <a:ext cx="530352" cy="228600"/>
+          </a:xfrm>
+          <a:prstGeom prst="rect">
+            <a:avLst/>
+          </a:prstGeom>
+          <a:noFill/>
+        </p:spPr>
+        <p:txBody>
+          <a:bodyPr wrap="square" lIns="22860" rIns="22860" tIns="22860" bIns="13716" anchor="t">
+            <a:spAutoFit/>
+          </a:bodyPr>
+          <a:lstStyle/>
+          <a:p>
+            <a:pPr algn="r">
+              <a:lnSpc>
+                <a:spcPct val="110000"/>
+              </a:lnSpc>
+              <a:spcAft>
+                <a:spcPts val="0"/>
+              </a:spcAft>
+            </a:pPr>
+            <a:r>
+              <a:rPr sz="1200" b="1">
+                <a:solidFill>
+                  <a:srgbClr val="087F7A"/>
+                </a:solidFill>
+                <a:latin typeface="DejaVu Sans"/>
+              </a:rPr>
+              <a:t>11</a:t>
             </a:r>
           </a:p>
         </p:txBody>
@@ -15296,7 +16271,7 @@
                 </a:solidFill>
                 <a:latin typeface="DejaVu Sans"/>
               </a:rPr>
-              <a:t>Ausentismo médico: dimensión del impacto laboral</a:t>
+              <a:t>DEA y oxígeno: equipamiento de emergencias</a:t>
             </a:r>
           </a:p>
         </p:txBody>
@@ -15338,7 +16313,7 @@
                 </a:solidFill>
                 <a:latin typeface="DejaVu Sans"/>
               </a:rPr>
-              <a:t>Enero–junio · Enfermedad + ART / horas teóricas</a:t>
+              <a:t>Controles DEA del primer semestre e inventario registrado</a:t>
             </a:r>
           </a:p>
         </p:txBody>
@@ -15423,7 +16398,7 @@
                 </a:solidFill>
                 <a:latin typeface="DejaVu Sans"/>
               </a:rPr>
-              <a:t>Enero–junio 2026  ·  8 de octubre de 2026  ·  Indicadores de ausentismo RRHH · Enero–junio</a:t>
+              <a:t>Controles 1S2026 · Inventario registrado  ·  8 de octubre de 2026  ·  Control Completo · Dea / Oxigeno</a:t>
             </a:r>
           </a:p>
         </p:txBody>
@@ -15478,8 +16453,8 @@
         </p:nvSpPr>
         <p:spPr>
           <a:xfrm>
-            <a:off x="566928" y="1883664"/>
-            <a:ext cx="2743200" cy="1719072"/>
+            <a:off x="566928" y="1874519"/>
+            <a:ext cx="5321808" cy="1755648"/>
           </a:xfrm>
           <a:prstGeom prst="roundRect">
             <a:avLst>
@@ -15523,8 +16498,8 @@
         </p:nvSpPr>
         <p:spPr>
           <a:xfrm>
-            <a:off x="566928" y="1883664"/>
-            <a:ext cx="50292" cy="1719072"/>
+            <a:off x="566928" y="1874519"/>
+            <a:ext cx="50292" cy="1755648"/>
           </a:xfrm>
           <a:prstGeom prst="rect">
             <a:avLst/>
@@ -15566,8 +16541,8 @@
         </p:nvSpPr>
         <p:spPr>
           <a:xfrm>
-            <a:off x="722376" y="2002536"/>
-            <a:ext cx="2432304" cy="557784"/>
+            <a:off x="722376" y="1993391"/>
+            <a:ext cx="5010912" cy="557784"/>
           </a:xfrm>
           <a:prstGeom prst="rect">
             <a:avLst/>
@@ -15595,7 +16570,7 @@
                 </a:solidFill>
                 <a:latin typeface="DejaVu Sans"/>
               </a:rPr>
-              <a:t>4,72%</a:t>
+              <a:t>4</a:t>
             </a:r>
           </a:p>
         </p:txBody>
@@ -15608,8 +16583,8 @@
         </p:nvSpPr>
         <p:spPr>
           <a:xfrm>
-            <a:off x="722376" y="2660904"/>
-            <a:ext cx="2432304" cy="640080"/>
+            <a:off x="722376" y="2651760"/>
+            <a:ext cx="5010912" cy="640080"/>
           </a:xfrm>
           <a:prstGeom prst="rect">
             <a:avLst/>
@@ -15637,7 +16612,7 @@
                 </a:solidFill>
                 <a:latin typeface="DejaVu Sans"/>
               </a:rPr>
-              <a:t>Semestre 2026</a:t>
+              <a:t>DEA con control registrado</a:t>
             </a:r>
           </a:p>
         </p:txBody>
@@ -15650,8 +16625,8 @@
         </p:nvSpPr>
         <p:spPr>
           <a:xfrm>
-            <a:off x="722376" y="3118104"/>
-            <a:ext cx="2432304" cy="411480"/>
+            <a:off x="722376" y="3145535"/>
+            <a:ext cx="5010912" cy="411480"/>
           </a:xfrm>
           <a:prstGeom prst="rect">
             <a:avLst/>
@@ -15679,7 +16654,7 @@
                 </a:solidFill>
                 <a:latin typeface="DejaVu Sans"/>
               </a:rPr>
-              <a:t>18.895 horas médicas</a:t>
+              <a:t>Último control: enero–junio 2026</a:t>
             </a:r>
           </a:p>
         </p:txBody>
@@ -15692,8 +16667,8 @@
         </p:nvSpPr>
         <p:spPr>
           <a:xfrm>
-            <a:off x="566928" y="3822191"/>
-            <a:ext cx="2743200" cy="1719072"/>
+            <a:off x="6291072" y="1874519"/>
+            <a:ext cx="5321808" cy="1755648"/>
           </a:xfrm>
           <a:prstGeom prst="roundRect">
             <a:avLst>
@@ -15737,14 +16712,14 @@
         </p:nvSpPr>
         <p:spPr>
           <a:xfrm>
-            <a:off x="566928" y="3822191"/>
-            <a:ext cx="50292" cy="1719072"/>
+            <a:off x="6291072" y="1874519"/>
+            <a:ext cx="50292" cy="1755648"/>
           </a:xfrm>
           <a:prstGeom prst="rect">
             <a:avLst/>
           </a:prstGeom>
           <a:solidFill>
-            <a:srgbClr val="6386A8"/>
+            <a:srgbClr val="087F7A"/>
           </a:solidFill>
           <a:ln>
             <a:noFill/>
@@ -15780,8 +16755,8 @@
         </p:nvSpPr>
         <p:spPr>
           <a:xfrm>
-            <a:off x="722376" y="3941063"/>
-            <a:ext cx="2432304" cy="557784"/>
+            <a:off x="6446520" y="1993391"/>
+            <a:ext cx="5010912" cy="557784"/>
           </a:xfrm>
           <a:prstGeom prst="rect">
             <a:avLst/>
@@ -15805,11 +16780,11 @@
             <a:r>
               <a:rPr sz="3500" b="1">
                 <a:solidFill>
-                  <a:srgbClr val="6386A8"/>
-                </a:solidFill>
-                <a:latin typeface="DejaVu Sans"/>
-              </a:rPr>
-              <a:t>3,92%</a:t>
+                  <a:srgbClr val="087F7A"/>
+                </a:solidFill>
+                <a:latin typeface="DejaVu Sans"/>
+              </a:rPr>
+              <a:t>7</a:t>
             </a:r>
           </a:p>
         </p:txBody>
@@ -15822,8 +16797,8 @@
         </p:nvSpPr>
         <p:spPr>
           <a:xfrm>
-            <a:off x="722376" y="4599431"/>
-            <a:ext cx="2432304" cy="640080"/>
+            <a:off x="6446520" y="2651760"/>
+            <a:ext cx="5010912" cy="640080"/>
           </a:xfrm>
           <a:prstGeom prst="rect">
             <a:avLst/>
@@ -15851,7 +16826,7 @@
                 </a:solidFill>
                 <a:latin typeface="DejaVu Sans"/>
               </a:rPr>
-              <a:t>Semestre 2025</a:t>
+              <a:t>Tubos de oxígeno inventariados</a:t>
             </a:r>
           </a:p>
         </p:txBody>
@@ -15864,8 +16839,8 @@
         </p:nvSpPr>
         <p:spPr>
           <a:xfrm>
-            <a:off x="722376" y="5056631"/>
-            <a:ext cx="2432304" cy="411480"/>
+            <a:off x="6446520" y="3145535"/>
+            <a:ext cx="5010912" cy="411480"/>
           </a:xfrm>
           <a:prstGeom prst="rect">
             <a:avLst/>
@@ -15893,45 +16868,528 @@
                 </a:solidFill>
                 <a:latin typeface="DejaVu Sans"/>
               </a:rPr>
-              <a:t>15.729 horas médicas</a:t>
-            </a:r>
-          </a:p>
-        </p:txBody>
-      </p:sp>
-      <p:pic>
-        <p:nvPicPr>
-          <p:cNvPr id="19" name="Picture 18" descr="ausentismo.png"/>
-          <p:cNvPicPr>
-            <a:picLocks noChangeAspect="1"/>
-          </p:cNvPicPr>
-          <p:nvPr/>
-        </p:nvPicPr>
-        <p:blipFill>
-          <a:blip r:embed="rId3"/>
-          <a:stretch>
-            <a:fillRect/>
-          </a:stretch>
-        </p:blipFill>
-        <p:spPr>
-          <a:xfrm>
-            <a:off x="3685032" y="2139847"/>
-            <a:ext cx="7909560" cy="3117801"/>
-          </a:xfrm>
-          <a:prstGeom prst="rect">
-            <a:avLst/>
-          </a:prstGeom>
-        </p:spPr>
-      </p:pic>
-      <p:sp>
-        <p:nvSpPr>
-          <p:cNvPr id="20" name="Rounded Rectangle 19"/>
+              <a:t>Equipamiento registrado en la planilla</a:t>
+            </a:r>
+          </a:p>
+        </p:txBody>
+      </p:sp>
+      <p:sp>
+        <p:nvSpPr>
+          <p:cNvPr id="19" name="Rectangle 18"/>
           <p:cNvSpPr/>
           <p:nvPr/>
         </p:nvSpPr>
         <p:spPr>
           <a:xfrm>
-            <a:off x="566928" y="5623560"/>
-            <a:ext cx="11064240" cy="630936"/>
+            <a:off x="566928" y="3840480"/>
+            <a:ext cx="11064240" cy="521207"/>
+          </a:xfrm>
+          <a:prstGeom prst="rect">
+            <a:avLst/>
+          </a:prstGeom>
+          <a:solidFill>
+            <a:srgbClr val="17324D"/>
+          </a:solidFill>
+          <a:ln>
+            <a:noFill/>
+          </a:ln>
+        </p:spPr>
+        <p:style>
+          <a:lnRef idx="1">
+            <a:schemeClr val="accent1"/>
+          </a:lnRef>
+          <a:fillRef idx="3">
+            <a:schemeClr val="accent1"/>
+          </a:fillRef>
+          <a:effectRef idx="2">
+            <a:schemeClr val="accent1"/>
+          </a:effectRef>
+          <a:fontRef idx="minor">
+            <a:schemeClr val="lt1"/>
+          </a:fontRef>
+        </p:style>
+        <p:txBody>
+          <a:bodyPr rtlCol="0" anchor="ctr"/>
+          <a:lstStyle/>
+          <a:p>
+            <a:pPr algn="ctr"/>
+          </a:p>
+        </p:txBody>
+      </p:sp>
+      <p:sp>
+        <p:nvSpPr>
+          <p:cNvPr id="20" name="TextBox 19"/>
+          <p:cNvSpPr txBox="1"/>
+          <p:nvPr/>
+        </p:nvSpPr>
+        <p:spPr>
+          <a:xfrm>
+            <a:off x="658368" y="3922776"/>
+            <a:ext cx="3477463" cy="402335"/>
+          </a:xfrm>
+          <a:prstGeom prst="rect">
+            <a:avLst/>
+          </a:prstGeom>
+          <a:noFill/>
+        </p:spPr>
+        <p:txBody>
+          <a:bodyPr wrap="square" lIns="22860" rIns="22860" tIns="22860" bIns="13716" anchor="t">
+            <a:spAutoFit/>
+          </a:bodyPr>
+          <a:lstStyle/>
+          <a:p>
+            <a:pPr algn="l">
+              <a:lnSpc>
+                <a:spcPct val="110000"/>
+              </a:lnSpc>
+              <a:spcAft>
+                <a:spcPts val="0"/>
+              </a:spcAft>
+            </a:pPr>
+            <a:r>
+              <a:rPr sz="2200" b="1">
+                <a:solidFill>
+                  <a:srgbClr val="FFFFFF"/>
+                </a:solidFill>
+                <a:latin typeface="DejaVu Sans"/>
+              </a:rPr>
+              <a:t>Equipamiento</a:t>
+            </a:r>
+          </a:p>
+        </p:txBody>
+      </p:sp>
+      <p:sp>
+        <p:nvSpPr>
+          <p:cNvPr id="21" name="TextBox 20"/>
+          <p:cNvSpPr txBox="1"/>
+          <p:nvPr/>
+        </p:nvSpPr>
+        <p:spPr>
+          <a:xfrm>
+            <a:off x="4309567" y="3922776"/>
+            <a:ext cx="2039112" cy="402335"/>
+          </a:xfrm>
+          <a:prstGeom prst="rect">
+            <a:avLst/>
+          </a:prstGeom>
+          <a:noFill/>
+        </p:spPr>
+        <p:txBody>
+          <a:bodyPr wrap="square" lIns="22860" rIns="22860" tIns="22860" bIns="13716" anchor="t">
+            <a:spAutoFit/>
+          </a:bodyPr>
+          <a:lstStyle/>
+          <a:p>
+            <a:pPr algn="l">
+              <a:lnSpc>
+                <a:spcPct val="110000"/>
+              </a:lnSpc>
+              <a:spcAft>
+                <a:spcPts val="0"/>
+              </a:spcAft>
+            </a:pPr>
+            <a:r>
+              <a:rPr sz="2200" b="1">
+                <a:solidFill>
+                  <a:srgbClr val="FFFFFF"/>
+                </a:solidFill>
+                <a:latin typeface="DejaVu Sans"/>
+              </a:rPr>
+              <a:t>Operativos</a:t>
+            </a:r>
+          </a:p>
+        </p:txBody>
+      </p:sp>
+      <p:sp>
+        <p:nvSpPr>
+          <p:cNvPr id="22" name="TextBox 21"/>
+          <p:cNvSpPr txBox="1"/>
+          <p:nvPr/>
+        </p:nvSpPr>
+        <p:spPr>
+          <a:xfrm>
+            <a:off x="6522415" y="3922776"/>
+            <a:ext cx="5026456" cy="402335"/>
+          </a:xfrm>
+          <a:prstGeom prst="rect">
+            <a:avLst/>
+          </a:prstGeom>
+          <a:noFill/>
+        </p:spPr>
+        <p:txBody>
+          <a:bodyPr wrap="square" lIns="22860" rIns="22860" tIns="22860" bIns="13716" anchor="t">
+            <a:spAutoFit/>
+          </a:bodyPr>
+          <a:lstStyle/>
+          <a:p>
+            <a:pPr algn="l">
+              <a:lnSpc>
+                <a:spcPct val="110000"/>
+              </a:lnSpc>
+              <a:spcAft>
+                <a:spcPts val="0"/>
+              </a:spcAft>
+            </a:pPr>
+            <a:r>
+              <a:rPr sz="2200" b="1">
+                <a:solidFill>
+                  <a:srgbClr val="FFFFFF"/>
+                </a:solidFill>
+                <a:latin typeface="DejaVu Sans"/>
+              </a:rPr>
+              <a:t>Otros estados</a:t>
+            </a:r>
+          </a:p>
+        </p:txBody>
+      </p:sp>
+      <p:sp>
+        <p:nvSpPr>
+          <p:cNvPr id="23" name="Rectangle 22"/>
+          <p:cNvSpPr/>
+          <p:nvPr/>
+        </p:nvSpPr>
+        <p:spPr>
+          <a:xfrm>
+            <a:off x="566928" y="4361688"/>
+            <a:ext cx="11064240" cy="521207"/>
+          </a:xfrm>
+          <a:prstGeom prst="rect">
+            <a:avLst/>
+          </a:prstGeom>
+          <a:solidFill>
+            <a:srgbClr val="F3F6F8"/>
+          </a:solidFill>
+          <a:ln>
+            <a:noFill/>
+          </a:ln>
+        </p:spPr>
+        <p:style>
+          <a:lnRef idx="1">
+            <a:schemeClr val="accent1"/>
+          </a:lnRef>
+          <a:fillRef idx="3">
+            <a:schemeClr val="accent1"/>
+          </a:fillRef>
+          <a:effectRef idx="2">
+            <a:schemeClr val="accent1"/>
+          </a:effectRef>
+          <a:fontRef idx="minor">
+            <a:schemeClr val="lt1"/>
+          </a:fontRef>
+        </p:style>
+        <p:txBody>
+          <a:bodyPr rtlCol="0" anchor="ctr"/>
+          <a:lstStyle/>
+          <a:p>
+            <a:pPr algn="ctr"/>
+          </a:p>
+        </p:txBody>
+      </p:sp>
+      <p:sp>
+        <p:nvSpPr>
+          <p:cNvPr id="24" name="TextBox 23"/>
+          <p:cNvSpPr txBox="1"/>
+          <p:nvPr/>
+        </p:nvSpPr>
+        <p:spPr>
+          <a:xfrm>
+            <a:off x="658368" y="4443984"/>
+            <a:ext cx="3477463" cy="402335"/>
+          </a:xfrm>
+          <a:prstGeom prst="rect">
+            <a:avLst/>
+          </a:prstGeom>
+          <a:noFill/>
+        </p:spPr>
+        <p:txBody>
+          <a:bodyPr wrap="square" lIns="22860" rIns="22860" tIns="22860" bIns="13716" anchor="t">
+            <a:spAutoFit/>
+          </a:bodyPr>
+          <a:lstStyle/>
+          <a:p>
+            <a:pPr algn="l">
+              <a:lnSpc>
+                <a:spcPct val="110000"/>
+              </a:lnSpc>
+              <a:spcAft>
+                <a:spcPts val="0"/>
+              </a:spcAft>
+            </a:pPr>
+            <a:r>
+              <a:rPr sz="2200" b="1">
+                <a:solidFill>
+                  <a:srgbClr val="17324D"/>
+                </a:solidFill>
+                <a:latin typeface="DejaVu Sans"/>
+              </a:rPr>
+              <a:t>DEA</a:t>
+            </a:r>
+          </a:p>
+        </p:txBody>
+      </p:sp>
+      <p:sp>
+        <p:nvSpPr>
+          <p:cNvPr id="25" name="TextBox 24"/>
+          <p:cNvSpPr txBox="1"/>
+          <p:nvPr/>
+        </p:nvSpPr>
+        <p:spPr>
+          <a:xfrm>
+            <a:off x="4309567" y="4443984"/>
+            <a:ext cx="2039112" cy="402335"/>
+          </a:xfrm>
+          <a:prstGeom prst="rect">
+            <a:avLst/>
+          </a:prstGeom>
+          <a:noFill/>
+        </p:spPr>
+        <p:txBody>
+          <a:bodyPr wrap="square" lIns="22860" rIns="22860" tIns="22860" bIns="13716" anchor="t">
+            <a:spAutoFit/>
+          </a:bodyPr>
+          <a:lstStyle/>
+          <a:p>
+            <a:pPr algn="l">
+              <a:lnSpc>
+                <a:spcPct val="110000"/>
+              </a:lnSpc>
+              <a:spcAft>
+                <a:spcPts val="0"/>
+              </a:spcAft>
+            </a:pPr>
+            <a:r>
+              <a:rPr sz="2200" b="0">
+                <a:solidFill>
+                  <a:srgbClr val="17324D"/>
+                </a:solidFill>
+                <a:latin typeface="DejaVu Sans"/>
+              </a:rPr>
+              <a:t>3</a:t>
+            </a:r>
+          </a:p>
+        </p:txBody>
+      </p:sp>
+      <p:sp>
+        <p:nvSpPr>
+          <p:cNvPr id="26" name="TextBox 25"/>
+          <p:cNvSpPr txBox="1"/>
+          <p:nvPr/>
+        </p:nvSpPr>
+        <p:spPr>
+          <a:xfrm>
+            <a:off x="6522415" y="4443984"/>
+            <a:ext cx="5026456" cy="402335"/>
+          </a:xfrm>
+          <a:prstGeom prst="rect">
+            <a:avLst/>
+          </a:prstGeom>
+          <a:noFill/>
+        </p:spPr>
+        <p:txBody>
+          <a:bodyPr wrap="square" lIns="22860" rIns="22860" tIns="22860" bIns="13716" anchor="t">
+            <a:spAutoFit/>
+          </a:bodyPr>
+          <a:lstStyle/>
+          <a:p>
+            <a:pPr algn="l">
+              <a:lnSpc>
+                <a:spcPct val="110000"/>
+              </a:lnSpc>
+              <a:spcAft>
+                <a:spcPts val="0"/>
+              </a:spcAft>
+            </a:pPr>
+            <a:r>
+              <a:rPr sz="2200" b="0">
+                <a:solidFill>
+                  <a:srgbClr val="17324D"/>
+                </a:solidFill>
+                <a:latin typeface="DejaVu Sans"/>
+              </a:rPr>
+              <a:t>1 fuera de servicio</a:t>
+            </a:r>
+          </a:p>
+        </p:txBody>
+      </p:sp>
+      <p:sp>
+        <p:nvSpPr>
+          <p:cNvPr id="27" name="Rectangle 26"/>
+          <p:cNvSpPr/>
+          <p:nvPr/>
+        </p:nvSpPr>
+        <p:spPr>
+          <a:xfrm>
+            <a:off x="566928" y="4882896"/>
+            <a:ext cx="11064240" cy="521207"/>
+          </a:xfrm>
+          <a:prstGeom prst="rect">
+            <a:avLst/>
+          </a:prstGeom>
+          <a:solidFill>
+            <a:srgbClr val="FFFFFF"/>
+          </a:solidFill>
+          <a:ln>
+            <a:noFill/>
+          </a:ln>
+        </p:spPr>
+        <p:style>
+          <a:lnRef idx="1">
+            <a:schemeClr val="accent1"/>
+          </a:lnRef>
+          <a:fillRef idx="3">
+            <a:schemeClr val="accent1"/>
+          </a:fillRef>
+          <a:effectRef idx="2">
+            <a:schemeClr val="accent1"/>
+          </a:effectRef>
+          <a:fontRef idx="minor">
+            <a:schemeClr val="lt1"/>
+          </a:fontRef>
+        </p:style>
+        <p:txBody>
+          <a:bodyPr rtlCol="0" anchor="ctr"/>
+          <a:lstStyle/>
+          <a:p>
+            <a:pPr algn="ctr"/>
+          </a:p>
+        </p:txBody>
+      </p:sp>
+      <p:sp>
+        <p:nvSpPr>
+          <p:cNvPr id="28" name="TextBox 27"/>
+          <p:cNvSpPr txBox="1"/>
+          <p:nvPr/>
+        </p:nvSpPr>
+        <p:spPr>
+          <a:xfrm>
+            <a:off x="658368" y="4965192"/>
+            <a:ext cx="3477463" cy="402335"/>
+          </a:xfrm>
+          <a:prstGeom prst="rect">
+            <a:avLst/>
+          </a:prstGeom>
+          <a:noFill/>
+        </p:spPr>
+        <p:txBody>
+          <a:bodyPr wrap="square" lIns="22860" rIns="22860" tIns="22860" bIns="13716" anchor="t">
+            <a:spAutoFit/>
+          </a:bodyPr>
+          <a:lstStyle/>
+          <a:p>
+            <a:pPr algn="l">
+              <a:lnSpc>
+                <a:spcPct val="110000"/>
+              </a:lnSpc>
+              <a:spcAft>
+                <a:spcPts val="0"/>
+              </a:spcAft>
+            </a:pPr>
+            <a:r>
+              <a:rPr sz="2200" b="1">
+                <a:solidFill>
+                  <a:srgbClr val="17324D"/>
+                </a:solidFill>
+                <a:latin typeface="DejaVu Sans"/>
+              </a:rPr>
+              <a:t>Tubos de oxígeno</a:t>
+            </a:r>
+          </a:p>
+        </p:txBody>
+      </p:sp>
+      <p:sp>
+        <p:nvSpPr>
+          <p:cNvPr id="29" name="TextBox 28"/>
+          <p:cNvSpPr txBox="1"/>
+          <p:nvPr/>
+        </p:nvSpPr>
+        <p:spPr>
+          <a:xfrm>
+            <a:off x="4309567" y="4965192"/>
+            <a:ext cx="2039112" cy="402335"/>
+          </a:xfrm>
+          <a:prstGeom prst="rect">
+            <a:avLst/>
+          </a:prstGeom>
+          <a:noFill/>
+        </p:spPr>
+        <p:txBody>
+          <a:bodyPr wrap="square" lIns="22860" rIns="22860" tIns="22860" bIns="13716" anchor="t">
+            <a:spAutoFit/>
+          </a:bodyPr>
+          <a:lstStyle/>
+          <a:p>
+            <a:pPr algn="l">
+              <a:lnSpc>
+                <a:spcPct val="110000"/>
+              </a:lnSpc>
+              <a:spcAft>
+                <a:spcPts val="0"/>
+              </a:spcAft>
+            </a:pPr>
+            <a:r>
+              <a:rPr sz="2200" b="0">
+                <a:solidFill>
+                  <a:srgbClr val="17324D"/>
+                </a:solidFill>
+                <a:latin typeface="DejaVu Sans"/>
+              </a:rPr>
+              <a:t>6</a:t>
+            </a:r>
+          </a:p>
+        </p:txBody>
+      </p:sp>
+      <p:sp>
+        <p:nvSpPr>
+          <p:cNvPr id="30" name="TextBox 29"/>
+          <p:cNvSpPr txBox="1"/>
+          <p:nvPr/>
+        </p:nvSpPr>
+        <p:spPr>
+          <a:xfrm>
+            <a:off x="6522415" y="4965192"/>
+            <a:ext cx="5026456" cy="402335"/>
+          </a:xfrm>
+          <a:prstGeom prst="rect">
+            <a:avLst/>
+          </a:prstGeom>
+          <a:noFill/>
+        </p:spPr>
+        <p:txBody>
+          <a:bodyPr wrap="square" lIns="22860" rIns="22860" tIns="22860" bIns="13716" anchor="t">
+            <a:spAutoFit/>
+          </a:bodyPr>
+          <a:lstStyle/>
+          <a:p>
+            <a:pPr algn="l">
+              <a:lnSpc>
+                <a:spcPct val="110000"/>
+              </a:lnSpc>
+              <a:spcAft>
+                <a:spcPts val="0"/>
+              </a:spcAft>
+            </a:pPr>
+            <a:r>
+              <a:rPr sz="2200" b="0">
+                <a:solidFill>
+                  <a:srgbClr val="17324D"/>
+                </a:solidFill>
+                <a:latin typeface="DejaVu Sans"/>
+              </a:rPr>
+              <a:t>1 no operativo</a:t>
+            </a:r>
+          </a:p>
+        </p:txBody>
+      </p:sp>
+      <p:sp>
+        <p:nvSpPr>
+          <p:cNvPr id="31" name="Rounded Rectangle 30"/>
+          <p:cNvSpPr/>
+          <p:nvPr/>
+        </p:nvSpPr>
+        <p:spPr>
+          <a:xfrm>
+            <a:off x="566928" y="5577840"/>
+            <a:ext cx="11064240" cy="685800"/>
           </a:xfrm>
           <a:prstGeom prst="roundRect">
             <a:avLst>
@@ -15969,14 +17427,14 @@
       </p:sp>
       <p:sp>
         <p:nvSpPr>
-          <p:cNvPr id="21" name="Rectangle 20"/>
+          <p:cNvPr id="32" name="Rectangle 31"/>
           <p:cNvSpPr/>
           <p:nvPr/>
         </p:nvSpPr>
         <p:spPr>
           <a:xfrm>
-            <a:off x="566928" y="5623560"/>
-            <a:ext cx="54864" cy="630936"/>
+            <a:off x="566928" y="5577840"/>
+            <a:ext cx="54864" cy="685800"/>
           </a:xfrm>
           <a:prstGeom prst="rect">
             <a:avLst/>
@@ -16012,42 +17470,42 @@
       </p:sp>
       <p:sp>
         <p:nvSpPr>
-          <p:cNvPr id="22" name="TextBox 21"/>
-          <p:cNvSpPr txBox="1"/>
-          <p:nvPr/>
-        </p:nvSpPr>
-        <p:spPr>
-          <a:xfrm>
-            <a:off x="713232" y="5696712"/>
-            <a:ext cx="10725912" cy="512063"/>
-          </a:xfrm>
-          <a:prstGeom prst="rect">
-            <a:avLst/>
-          </a:prstGeom>
-          <a:noFill/>
-        </p:spPr>
-        <p:txBody>
-          <a:bodyPr wrap="square" lIns="22860" rIns="22860" tIns="22860" bIns="13716" anchor="t">
-            <a:spAutoFit/>
-          </a:bodyPr>
-          <a:lstStyle/>
-          <a:p>
-            <a:pPr algn="l">
-              <a:lnSpc>
-                <a:spcPct val="110000"/>
-              </a:lnSpc>
-              <a:spcAft>
-                <a:spcPts val="0"/>
-              </a:spcAft>
-            </a:pPr>
-            <a:r>
-              <a:rPr sz="1850" b="0">
+          <p:cNvPr id="33" name="TextBox 32"/>
+          <p:cNvSpPr txBox="1"/>
+          <p:nvPr/>
+        </p:nvSpPr>
+        <p:spPr>
+          <a:xfrm>
+            <a:off x="713232" y="5650992"/>
+            <a:ext cx="10725912" cy="566928"/>
+          </a:xfrm>
+          <a:prstGeom prst="rect">
+            <a:avLst/>
+          </a:prstGeom>
+          <a:noFill/>
+        </p:spPr>
+        <p:txBody>
+          <a:bodyPr wrap="square" lIns="22860" rIns="22860" tIns="22860" bIns="13716" anchor="t">
+            <a:spAutoFit/>
+          </a:bodyPr>
+          <a:lstStyle/>
+          <a:p>
+            <a:pPr algn="l">
+              <a:lnSpc>
+                <a:spcPct val="110000"/>
+              </a:lnSpc>
+              <a:spcAft>
+                <a:spcPts val="0"/>
+              </a:spcAft>
+            </a:pPr>
+            <a:r>
+              <a:rPr sz="1650" b="0">
                 <a:solidFill>
                   <a:srgbClr val="17324D"/>
                 </a:solidFill>
                 <a:latin typeface="DejaVu Sans"/>
               </a:rPr>
-              <a:t>Cambio interanual: +0,795 puntos porcentuales. BP se incluye en enfermedad.</a:t>
+              <a:t>Estado de inventario sin fecha de corte confirmada. La planilla de oxígeno no registra fechas de control.</a:t>
             </a:r>
           </a:p>
         </p:txBody>

</xml_diff>